<commit_message>
Update stakeholder deck with manual edits
Co-Authored-By: Claude Sonnet 4.6 <noreply@anthropic.com>
</commit_message>
<xml_diff>
--- a/Project Hercules - Stakeholder Deck.pptx
+++ b/Project Hercules - Stakeholder Deck.pptx
@@ -4,6 +4,9 @@
   <p:sldMasterIdLst>
     <p:sldMasterId id="2147483648" r:id="rId1"/>
   </p:sldMasterIdLst>
+  <p:notesMasterIdLst>
+    <p:notesMasterId r:id="rId8"/>
+  </p:notesMasterIdLst>
   <p:sldIdLst>
     <p:sldId id="256" r:id="rId2"/>
     <p:sldId id="257" r:id="rId3"/>
@@ -11,14 +14,8 @@
     <p:sldId id="259" r:id="rId5"/>
     <p:sldId id="260" r:id="rId6"/>
     <p:sldId id="261" r:id="rId7"/>
-    <p:sldId id="262" r:id="rId8"/>
-    <p:sldId id="263" r:id="rId9"/>
-    <p:sldId id="264" r:id="rId10"/>
   </p:sldIdLst>
-  <p:notesMasterIdLst>
-    <p:notesMasterId r:id="rId11"/>
-  </p:notesMasterIdLst>
-  <p:sldSz cx="9144000" cy="5143500"/>
+  <p:sldSz cx="9144000" cy="5143500" type="screen16x9"/>
   <p:notesSz cx="5143500" cy="9144000"/>
   <p:defaultTextStyle>
     <a:lvl1pPr marL="0" algn="l" defTabSz="914400" rtl="0" eaLnBrk="1" latinLnBrk="0" hangingPunct="1">
@@ -112,6 +109,11 @@
       </a:defRPr>
     </a:lvl9pPr>
   </p:defaultTextStyle>
+  <p:extLst>
+    <p:ext uri="{EFAFB233-063F-42B5-8137-9DF3F51BA10A}">
+      <p15:sldGuideLst xmlns:p15="http://schemas.microsoft.com/office/powerpoint/2012/main"/>
+    </p:ext>
+  </p:extLst>
 </p:presentation>
 </file>
 
@@ -137,234 +139,10 @@
           <a:chExt cx="0" cy="0"/>
         </a:xfrm>
       </p:grpSpPr>
-      <p:sp>
-        <p:nvSpPr>
-          <p:cNvPr id="2" name="Header Placeholder 1"/>
-          <p:cNvSpPr>
-            <a:spLocks noGrp="1"/>
-          </p:cNvSpPr>
-          <p:nvPr>
-            <p:ph type="hdr" sz="quarter"/>
-          </p:nvPr>
-        </p:nvSpPr>
-        <p:spPr>
-          <a:xfrm>
-            <a:off x="0" y="0"/>
-            <a:ext cx="2971800" cy="458788"/>
-          </a:xfrm>
-          <a:prstGeom prst="rect">
-            <a:avLst/>
-          </a:prstGeom>
-        </p:spPr>
-        <p:txBody>
-          <a:bodyPr vert="horz" lIns="91440" tIns="45720" rIns="91440" bIns="45720" rtlCol="0"/>
-          <a:lstStyle>
-            <a:lvl1pPr algn="l">
-              <a:defRPr sz="1200"/>
-            </a:lvl1pPr>
-          </a:lstStyle>
-          <a:p>
-            <a:endParaRPr lang="en-US"/>
-          </a:p>
-        </p:txBody>
-      </p:sp>
-      <p:sp>
-        <p:nvSpPr>
-          <p:cNvPr id="3" name="Date Placeholder 2"/>
-          <p:cNvSpPr>
-            <a:spLocks noGrp="1"/>
-          </p:cNvSpPr>
-          <p:nvPr>
-            <p:ph type="dt" idx="1"/>
-          </p:nvPr>
-        </p:nvSpPr>
-        <p:spPr>
-          <a:xfrm>
-            <a:off x="3884613" y="0"/>
-            <a:ext cx="2971800" cy="458788"/>
-          </a:xfrm>
-          <a:prstGeom prst="rect">
-            <a:avLst/>
-          </a:prstGeom>
-        </p:spPr>
-        <p:txBody>
-          <a:bodyPr vert="horz" lIns="91440" tIns="45720" rIns="91440" bIns="45720" rtlCol="0"/>
-          <a:lstStyle>
-            <a:lvl1pPr algn="r">
-              <a:defRPr sz="1200"/>
-            </a:lvl1pPr>
-          </a:lstStyle>
-          <a:p>
-            <a:fld id="{5282F153-3F37-0F45-9E97-73ACFA13230C}" type="datetimeFigureOut">
-              <a:rPr lang="en-US"/>
-              <a:t>7/23/19</a:t>
-            </a:fld>
-            <a:endParaRPr lang="en-US"/>
-          </a:p>
-        </p:txBody>
-      </p:sp>
-      <p:sp>
-        <p:nvSpPr>
-          <p:cNvPr id="4" name="Slide Image Placeholder 3"/>
-          <p:cNvSpPr>
-            <a:spLocks noGrp="1" noRot="1" noChangeAspect="1"/>
-          </p:cNvSpPr>
-          <p:nvPr>
-            <p:ph type="sldImg" idx="2"/>
-          </p:nvPr>
-        </p:nvSpPr>
-        <p:spPr>
-          <a:xfrm>
-            <a:off x="685800" y="1143000"/>
-            <a:ext cx="5486400" cy="3086100"/>
-          </a:xfrm>
-          <a:prstGeom prst="rect">
-            <a:avLst/>
-          </a:prstGeom>
-          <a:noFill/>
-          <a:ln w="12700">
-            <a:solidFill>
-              <a:prstClr val="black"/>
-            </a:solidFill>
-          </a:ln>
-        </p:spPr>
-        <p:txBody>
-          <a:bodyPr vert="horz" lIns="91440" tIns="45720" rIns="91440" bIns="45720" rtlCol="0" anchor="ctr"/>
-          <a:lstStyle/>
-          <a:p>
-            <a:endParaRPr lang="en-US"/>
-          </a:p>
-        </p:txBody>
-      </p:sp>
-      <p:sp>
-        <p:nvSpPr>
-          <p:cNvPr id="5" name="Notes Placeholder 4"/>
-          <p:cNvSpPr>
-            <a:spLocks noGrp="1"/>
-          </p:cNvSpPr>
-          <p:nvPr>
-            <p:ph type="body" sz="quarter" idx="3"/>
-          </p:nvPr>
-        </p:nvSpPr>
-        <p:spPr>
-          <a:xfrm>
-            <a:off x="685800" y="4400550"/>
-            <a:ext cx="5486400" cy="3600450"/>
-          </a:xfrm>
-          <a:prstGeom prst="rect">
-            <a:avLst/>
-          </a:prstGeom>
-        </p:spPr>
-        <p:txBody>
-          <a:bodyPr vert="horz" lIns="91440" tIns="45720" rIns="91440" bIns="45720" rtlCol="0"/>
-          <a:lstStyle/>
-          <a:p>
-            <a:pPr lvl="0"/>
-            <a:r>
-              <a:rPr lang="en-US"/>
-              <a:t>Click to edit Master text styles</a:t>
-            </a:r>
-          </a:p>
-          <a:p>
-            <a:pPr lvl="1"/>
-            <a:r>
-              <a:rPr lang="en-US"/>
-              <a:t>Second level</a:t>
-            </a:r>
-          </a:p>
-          <a:p>
-            <a:pPr lvl="2"/>
-            <a:r>
-              <a:rPr lang="en-US"/>
-              <a:t>Third level</a:t>
-            </a:r>
-          </a:p>
-          <a:p>
-            <a:pPr lvl="3"/>
-            <a:r>
-              <a:rPr lang="en-US"/>
-              <a:t>Fourth level</a:t>
-            </a:r>
-          </a:p>
-          <a:p>
-            <a:pPr lvl="4"/>
-            <a:r>
-              <a:rPr lang="en-US"/>
-              <a:t>Fifth level</a:t>
-            </a:r>
-          </a:p>
-        </p:txBody>
-      </p:sp>
-      <p:sp>
-        <p:nvSpPr>
-          <p:cNvPr id="6" name="Footer Placeholder 5"/>
-          <p:cNvSpPr>
-            <a:spLocks noGrp="1"/>
-          </p:cNvSpPr>
-          <p:nvPr>
-            <p:ph type="ftr" sz="quarter" idx="4"/>
-          </p:nvPr>
-        </p:nvSpPr>
-        <p:spPr>
-          <a:xfrm>
-            <a:off x="0" y="8685213"/>
-            <a:ext cx="2971800" cy="458787"/>
-          </a:xfrm>
-          <a:prstGeom prst="rect">
-            <a:avLst/>
-          </a:prstGeom>
-        </p:spPr>
-        <p:txBody>
-          <a:bodyPr vert="horz" lIns="91440" tIns="45720" rIns="91440" bIns="45720" rtlCol="0" anchor="b"/>
-          <a:lstStyle>
-            <a:lvl1pPr algn="l">
-              <a:defRPr sz="1200"/>
-            </a:lvl1pPr>
-          </a:lstStyle>
-          <a:p>
-            <a:endParaRPr lang="en-US"/>
-          </a:p>
-        </p:txBody>
-      </p:sp>
-      <p:sp>
-        <p:nvSpPr>
-          <p:cNvPr id="7" name="Slide Number Placeholder 6"/>
-          <p:cNvSpPr>
-            <a:spLocks noGrp="1"/>
-          </p:cNvSpPr>
-          <p:nvPr>
-            <p:ph type="sldNum" sz="quarter" idx="5"/>
-          </p:nvPr>
-        </p:nvSpPr>
-        <p:spPr>
-          <a:xfrm>
-            <a:off x="3884613" y="8685213"/>
-            <a:ext cx="2971800" cy="458787"/>
-          </a:xfrm>
-          <a:prstGeom prst="rect">
-            <a:avLst/>
-          </a:prstGeom>
-        </p:spPr>
-        <p:txBody>
-          <a:bodyPr vert="horz" lIns="91440" tIns="45720" rIns="91440" bIns="45720" rtlCol="0" anchor="b"/>
-          <a:lstStyle>
-            <a:lvl1pPr algn="r">
-              <a:defRPr sz="1200"/>
-            </a:lvl1pPr>
-          </a:lstStyle>
-          <a:p>
-            <a:fld id="{CE5E9CC1-C706-0F49-92D6-E571CC5EEA8F}" type="slidenum">
-              <a:rPr lang="en-US"/>
-              <a:t>‹#›</a:t>
-            </a:fld>
-            <a:endParaRPr lang="en-US"/>
-          </a:p>
-        </p:txBody>
-      </p:sp>
     </p:spTree>
     <p:extLst>
       <p:ext uri="{BB962C8B-B14F-4D97-AF65-F5344CB8AC3E}">
-        <p14:creationId xmlns:p14="http://schemas.microsoft.com/office/powerpoint/2010/main" val="1024086991"/>
+        <p14:creationId xmlns:p14="http://schemas.microsoft.com/office/powerpoint/2010/main" val="1552376293"/>
       </p:ext>
     </p:extLst>
   </p:cSld>
@@ -512,7 +290,6 @@
               <a:rPr lang="en-US" dirty="0"/>
               <a:t>Welcome the audience. Project Hercules is an open-source, self-hosted expense tracker using a local small language model for natural language input. This deck covers the problem, solution, design approach, and delivery plan.</a:t>
             </a:r>
-            <a:endParaRPr lang="en-US" dirty="0"/>
           </a:p>
         </p:txBody>
       </p:sp>
@@ -600,7 +377,6 @@
               <a:rPr lang="en-US" dirty="0"/>
               <a:t>The core problem is threefold: friction, privacy, and cost. Most people abandon expense tracking within weeks because the entry experience is too cumbersome.</a:t>
             </a:r>
-            <a:endParaRPr lang="en-US" dirty="0"/>
           </a:p>
         </p:txBody>
       </p:sp>
@@ -688,7 +464,6 @@
               <a:rPr lang="en-US" dirty="0"/>
               <a:t>The solution is simple: let people log expenses the way they'd tell a friend, using a local AI model to parse it. No cloud, no subscription, no friction.</a:t>
             </a:r>
-            <a:endParaRPr lang="en-US" dirty="0"/>
           </a:p>
         </p:txBody>
       </p:sp>
@@ -776,7 +551,6 @@
               <a:rPr lang="en-US" dirty="0"/>
               <a:t>Three non-negotiable design principles underpin every decision in this project. The CPMAI framework is being used to guide how AI is scoped and governed within the application.</a:t>
             </a:r>
-            <a:endParaRPr lang="en-US" dirty="0"/>
           </a:p>
         </p:txBody>
       </p:sp>
@@ -864,7 +638,6 @@
               <a:rPr lang="en-US" dirty="0"/>
               <a:t>Walk through the process flow. Key point: the SLM is called only once, constrained to the user's own category list. The application handles all non-cognitive steps. No data is saved without user confirmation.</a:t>
             </a:r>
-            <a:endParaRPr lang="en-US" dirty="0"/>
           </a:p>
         </p:txBody>
       </p:sp>
@@ -952,7 +725,6 @@
               <a:rPr lang="en-US" dirty="0"/>
               <a:t>Delivery is structured into four phases. The priority is to get a working prototype (Phase 1 and 2) out as quickly as possible to validate the core concept before investing in more advanced features.</a:t>
             </a:r>
-            <a:endParaRPr lang="en-US" dirty="0"/>
           </a:p>
         </p:txBody>
       </p:sp>
@@ -974,270 +746,6 @@
             <a:fld id="{F7021451-1387-4CA6-816F-3879F97B5CBC}" type="slidenum">
               <a:rPr lang="en-US"/>
               <a:t>6</a:t>
-            </a:fld>
-            <a:endParaRPr lang="en-US"/>
-          </a:p>
-        </p:txBody>
-      </p:sp>
-    </p:spTree>
-    <p:extLst>
-      <p:ext uri="{BB962C8B-B14F-4D97-AF65-F5344CB8AC3E}">
-        <p14:creationId xmlns:p14="http://schemas.microsoft.com/office/powerpoint/2010/main" val="1024086991"/>
-      </p:ext>
-    </p:extLst>
-  </p:cSld>
-  <p:clrMapOvr>
-    <a:masterClrMapping/>
-  </p:clrMapOvr>
-</p:notes>
-</file>
-
-<file path=ppt/notesSlides/notesSlide7.xml><?xml version="1.0" encoding="utf-8"?>
-<p:notes xmlns:a="http://schemas.openxmlformats.org/drawingml/2006/main" xmlns:r="http://schemas.openxmlformats.org/officeDocument/2006/relationships" xmlns:p="http://schemas.openxmlformats.org/presentationml/2006/main">
-  <p:cSld>
-    <p:spTree>
-      <p:nvGrpSpPr>
-        <p:cNvPr id="1" name=""/>
-        <p:cNvGrpSpPr/>
-        <p:nvPr/>
-      </p:nvGrpSpPr>
-      <p:grpSpPr>
-        <a:xfrm>
-          <a:off x="0" y="0"/>
-          <a:ext cx="0" cy="0"/>
-          <a:chOff x="0" y="0"/>
-          <a:chExt cx="0" cy="0"/>
-        </a:xfrm>
-      </p:grpSpPr>
-      <p:sp>
-        <p:nvSpPr>
-          <p:cNvPr id="2" name="Slide Image Placeholder 1"/>
-          <p:cNvSpPr>
-            <a:spLocks noGrp="1" noRot="1" noChangeAspect="1"/>
-          </p:cNvSpPr>
-          <p:nvPr>
-            <p:ph type="sldImg"/>
-          </p:nvPr>
-        </p:nvSpPr>
-        <p:spPr/>
-      </p:sp>
-      <p:sp>
-        <p:nvSpPr>
-          <p:cNvPr id="3" name="Notes Placeholder 2"/>
-          <p:cNvSpPr>
-            <a:spLocks noGrp="1"/>
-          </p:cNvSpPr>
-          <p:nvPr>
-            <p:ph type="body" idx="1"/>
-          </p:nvPr>
-        </p:nvSpPr>
-        <p:spPr/>
-        <p:txBody>
-          <a:bodyPr/>
-          <a:lstStyle/>
-          <a:p>
-            <a:r>
-              <a:rPr lang="en-US" dirty="0"/>
-              <a:t>Three measurable success criteria. The 10% correction rate is the key parsing quality benchmark — it drives future iterations of the AI prompt design.</a:t>
-            </a:r>
-            <a:endParaRPr lang="en-US" dirty="0"/>
-          </a:p>
-        </p:txBody>
-      </p:sp>
-      <p:sp>
-        <p:nvSpPr>
-          <p:cNvPr id="4" name="Slide Number Placeholder 3"/>
-          <p:cNvSpPr>
-            <a:spLocks noGrp="1"/>
-          </p:cNvSpPr>
-          <p:nvPr>
-            <p:ph type="sldNum" sz="quarter" idx="10"/>
-          </p:nvPr>
-        </p:nvSpPr>
-        <p:spPr/>
-        <p:txBody>
-          <a:bodyPr/>
-          <a:lstStyle/>
-          <a:p>
-            <a:fld id="{F7021451-1387-4CA6-816F-3879F97B5CBC}" type="slidenum">
-              <a:rPr lang="en-US"/>
-              <a:t>7</a:t>
-            </a:fld>
-            <a:endParaRPr lang="en-US"/>
-          </a:p>
-        </p:txBody>
-      </p:sp>
-    </p:spTree>
-    <p:extLst>
-      <p:ext uri="{BB962C8B-B14F-4D97-AF65-F5344CB8AC3E}">
-        <p14:creationId xmlns:p14="http://schemas.microsoft.com/office/powerpoint/2010/main" val="1024086991"/>
-      </p:ext>
-    </p:extLst>
-  </p:cSld>
-  <p:clrMapOvr>
-    <a:masterClrMapping/>
-  </p:clrMapOvr>
-</p:notes>
-</file>
-
-<file path=ppt/notesSlides/notesSlide8.xml><?xml version="1.0" encoding="utf-8"?>
-<p:notes xmlns:a="http://schemas.openxmlformats.org/drawingml/2006/main" xmlns:r="http://schemas.openxmlformats.org/officeDocument/2006/relationships" xmlns:p="http://schemas.openxmlformats.org/presentationml/2006/main">
-  <p:cSld>
-    <p:spTree>
-      <p:nvGrpSpPr>
-        <p:cNvPr id="1" name=""/>
-        <p:cNvGrpSpPr/>
-        <p:nvPr/>
-      </p:nvGrpSpPr>
-      <p:grpSpPr>
-        <a:xfrm>
-          <a:off x="0" y="0"/>
-          <a:ext cx="0" cy="0"/>
-          <a:chOff x="0" y="0"/>
-          <a:chExt cx="0" cy="0"/>
-        </a:xfrm>
-      </p:grpSpPr>
-      <p:sp>
-        <p:nvSpPr>
-          <p:cNvPr id="2" name="Slide Image Placeholder 1"/>
-          <p:cNvSpPr>
-            <a:spLocks noGrp="1" noRot="1" noChangeAspect="1"/>
-          </p:cNvSpPr>
-          <p:nvPr>
-            <p:ph type="sldImg"/>
-          </p:nvPr>
-        </p:nvSpPr>
-        <p:spPr/>
-      </p:sp>
-      <p:sp>
-        <p:nvSpPr>
-          <p:cNvPr id="3" name="Notes Placeholder 2"/>
-          <p:cNvSpPr>
-            <a:spLocks noGrp="1"/>
-          </p:cNvSpPr>
-          <p:nvPr>
-            <p:ph type="body" idx="1"/>
-          </p:nvPr>
-        </p:nvSpPr>
-        <p:spPr/>
-        <p:txBody>
-          <a:bodyPr/>
-          <a:lstStyle/>
-          <a:p>
-            <a:r>
-              <a:rPr lang="en-US" dirty="0"/>
-              <a:t>The project is driven by two collaborators bringing complementary skills — technical and delivery.</a:t>
-            </a:r>
-            <a:endParaRPr lang="en-US" dirty="0"/>
-          </a:p>
-        </p:txBody>
-      </p:sp>
-      <p:sp>
-        <p:nvSpPr>
-          <p:cNvPr id="4" name="Slide Number Placeholder 3"/>
-          <p:cNvSpPr>
-            <a:spLocks noGrp="1"/>
-          </p:cNvSpPr>
-          <p:nvPr>
-            <p:ph type="sldNum" sz="quarter" idx="10"/>
-          </p:nvPr>
-        </p:nvSpPr>
-        <p:spPr/>
-        <p:txBody>
-          <a:bodyPr/>
-          <a:lstStyle/>
-          <a:p>
-            <a:fld id="{F7021451-1387-4CA6-816F-3879F97B5CBC}" type="slidenum">
-              <a:rPr lang="en-US"/>
-              <a:t>8</a:t>
-            </a:fld>
-            <a:endParaRPr lang="en-US"/>
-          </a:p>
-        </p:txBody>
-      </p:sp>
-    </p:spTree>
-    <p:extLst>
-      <p:ext uri="{BB962C8B-B14F-4D97-AF65-F5344CB8AC3E}">
-        <p14:creationId xmlns:p14="http://schemas.microsoft.com/office/powerpoint/2010/main" val="1024086991"/>
-      </p:ext>
-    </p:extLst>
-  </p:cSld>
-  <p:clrMapOvr>
-    <a:masterClrMapping/>
-  </p:clrMapOvr>
-</p:notes>
-</file>
-
-<file path=ppt/notesSlides/notesSlide9.xml><?xml version="1.0" encoding="utf-8"?>
-<p:notes xmlns:a="http://schemas.openxmlformats.org/drawingml/2006/main" xmlns:r="http://schemas.openxmlformats.org/officeDocument/2006/relationships" xmlns:p="http://schemas.openxmlformats.org/presentationml/2006/main">
-  <p:cSld>
-    <p:spTree>
-      <p:nvGrpSpPr>
-        <p:cNvPr id="1" name=""/>
-        <p:cNvGrpSpPr/>
-        <p:nvPr/>
-      </p:nvGrpSpPr>
-      <p:grpSpPr>
-        <a:xfrm>
-          <a:off x="0" y="0"/>
-          <a:ext cx="0" cy="0"/>
-          <a:chOff x="0" y="0"/>
-          <a:chExt cx="0" cy="0"/>
-        </a:xfrm>
-      </p:grpSpPr>
-      <p:sp>
-        <p:nvSpPr>
-          <p:cNvPr id="2" name="Slide Image Placeholder 1"/>
-          <p:cNvSpPr>
-            <a:spLocks noGrp="1" noRot="1" noChangeAspect="1"/>
-          </p:cNvSpPr>
-          <p:nvPr>
-            <p:ph type="sldImg"/>
-          </p:nvPr>
-        </p:nvSpPr>
-        <p:spPr/>
-      </p:sp>
-      <p:sp>
-        <p:nvSpPr>
-          <p:cNvPr id="3" name="Notes Placeholder 2"/>
-          <p:cNvSpPr>
-            <a:spLocks noGrp="1"/>
-          </p:cNvSpPr>
-          <p:nvPr>
-            <p:ph type="body" idx="1"/>
-          </p:nvPr>
-        </p:nvSpPr>
-        <p:spPr/>
-        <p:txBody>
-          <a:bodyPr/>
-          <a:lstStyle/>
-          <a:p>
-            <a:r>
-              <a:rPr lang="en-US" dirty="0"/>
-              <a:t>Four concrete next steps to move from planning into execution. The priority is Phase 1 — getting the parsing loop working end-to-end as quickly as possible.</a:t>
-            </a:r>
-            <a:endParaRPr lang="en-US" dirty="0"/>
-          </a:p>
-        </p:txBody>
-      </p:sp>
-      <p:sp>
-        <p:nvSpPr>
-          <p:cNvPr id="4" name="Slide Number Placeholder 3"/>
-          <p:cNvSpPr>
-            <a:spLocks noGrp="1"/>
-          </p:cNvSpPr>
-          <p:nvPr>
-            <p:ph type="sldNum" sz="quarter" idx="10"/>
-          </p:nvPr>
-        </p:nvSpPr>
-        <p:spPr/>
-        <p:txBody>
-          <a:bodyPr/>
-          <a:lstStyle/>
-          <a:p>
-            <a:fld id="{F7021451-1387-4CA6-816F-3879F97B5CBC}" type="slidenum">
-              <a:rPr lang="en-US"/>
-              <a:t>9</a:t>
             </a:fld>
             <a:endParaRPr lang="en-US"/>
           </a:p>
@@ -1289,6 +797,11 @@
 <file path=ppt/slideMasters/slideMaster1.xml><?xml version="1.0" encoding="utf-8"?>
 <p:sldMaster xmlns:a="http://schemas.openxmlformats.org/drawingml/2006/main" xmlns:r="http://schemas.openxmlformats.org/officeDocument/2006/relationships" xmlns:p="http://schemas.openxmlformats.org/presentationml/2006/main">
   <p:cSld>
+    <p:bg>
+      <p:bgRef idx="1001">
+        <a:schemeClr val="bg1"/>
+      </p:bgRef>
+    </p:bg>
     <p:spTree>
       <p:nvGrpSpPr>
         <p:cNvPr id="1" name=""/>
@@ -1571,6 +1084,7 @@
         <a:solidFill>
           <a:srgbClr val="0F172A"/>
         </a:solidFill>
+        <a:effectLst/>
       </p:bgPr>
     </p:bg>
     <p:spTree>
@@ -1608,7 +1122,7 @@
           <a:bodyPr wrap="square" rtlCol="0" anchor="ctr"/>
           <a:lstStyle/>
           <a:p>
-            <a:pPr algn="l" indent="0" marL="0">
+            <a:pPr marL="0" indent="0" algn="l">
               <a:buNone/>
             </a:pPr>
             <a:r>
@@ -1647,7 +1161,7 @@
           <a:bodyPr wrap="square" rtlCol="0" anchor="ctr"/>
           <a:lstStyle/>
           <a:p>
-            <a:pPr algn="l" indent="0" marL="0">
+            <a:pPr marL="0" indent="0" algn="l">
               <a:buNone/>
             </a:pPr>
             <a:r>
@@ -1689,6 +1203,13 @@
             <a:prstDash val="solid"/>
           </a:ln>
         </p:spPr>
+        <p:txBody>
+          <a:bodyPr/>
+          <a:lstStyle/>
+          <a:p>
+            <a:endParaRPr lang="en-US"/>
+          </a:p>
+        </p:txBody>
       </p:sp>
       <p:sp>
         <p:nvSpPr>
@@ -1714,6 +1235,13 @@
             <a:prstDash val="solid"/>
           </a:ln>
         </p:spPr>
+        <p:txBody>
+          <a:bodyPr/>
+          <a:lstStyle/>
+          <a:p>
+            <a:endParaRPr lang="en-US"/>
+          </a:p>
+        </p:txBody>
       </p:sp>
       <p:sp>
         <p:nvSpPr>
@@ -1736,7 +1264,7 @@
           <a:bodyPr wrap="square" rtlCol="0" anchor="ctr"/>
           <a:lstStyle/>
           <a:p>
-            <a:pPr algn="l" indent="0" marL="0">
+            <a:pPr marL="0" indent="0" algn="l">
               <a:buNone/>
             </a:pPr>
             <a:r>
@@ -1770,6 +1298,7 @@
         <a:solidFill>
           <a:srgbClr val="FFFFFF"/>
         </a:solidFill>
+        <a:effectLst/>
       </p:bgPr>
     </p:bg>
     <p:spTree>
@@ -1807,7 +1336,7 @@
           <a:bodyPr wrap="square" rtlCol="0" anchor="ctr"/>
           <a:lstStyle/>
           <a:p>
-            <a:pPr algn="l" indent="0" marL="0">
+            <a:pPr marL="0" indent="0" algn="l">
               <a:buNone/>
             </a:pPr>
             <a:r>
@@ -1851,13 +1380,20 @@
             <a:prstDash val="solid"/>
           </a:ln>
           <a:effectLst>
-            <a:outerShdw sx="100000" sy="100000" kx="0" ky="0" algn="bl" rotWithShape="0" blurRad="101600" dist="25400" dir="2700000">
+            <a:outerShdw blurRad="101600" dist="25400" dir="2700000" algn="bl" rotWithShape="0">
               <a:srgbClr val="000000">
                 <a:alpha val="10000"/>
               </a:srgbClr>
             </a:outerShdw>
           </a:effectLst>
         </p:spPr>
+        <p:txBody>
+          <a:bodyPr/>
+          <a:lstStyle/>
+          <a:p>
+            <a:endParaRPr lang="en-US"/>
+          </a:p>
+        </p:txBody>
       </p:sp>
       <p:sp>
         <p:nvSpPr>
@@ -1880,7 +1416,7 @@
           <a:bodyPr wrap="square" rtlCol="0" anchor="ctr"/>
           <a:lstStyle/>
           <a:p>
-            <a:pPr algn="l" indent="0" marL="0">
+            <a:pPr marL="0" indent="0" algn="l">
               <a:buNone/>
             </a:pPr>
             <a:r>
@@ -1916,7 +1452,7 @@
           <a:bodyPr wrap="square" rtlCol="0" anchor="ctr"/>
           <a:lstStyle/>
           <a:p>
-            <a:pPr algn="l" indent="0" marL="0">
+            <a:pPr marL="0" indent="0" algn="l">
               <a:buNone/>
             </a:pPr>
             <a:r>
@@ -1955,7 +1491,7 @@
           <a:bodyPr wrap="square" rtlCol="0" anchor="ctr"/>
           <a:lstStyle/>
           <a:p>
-            <a:pPr algn="l" indent="0" marL="0">
+            <a:pPr marL="0" indent="0" algn="l">
               <a:buNone/>
             </a:pPr>
             <a:r>
@@ -1999,13 +1535,20 @@
             <a:prstDash val="solid"/>
           </a:ln>
           <a:effectLst>
-            <a:outerShdw sx="100000" sy="100000" kx="0" ky="0" algn="bl" rotWithShape="0" blurRad="101600" dist="25400" dir="2700000">
+            <a:outerShdw blurRad="101600" dist="25400" dir="2700000" algn="bl" rotWithShape="0">
               <a:srgbClr val="000000">
                 <a:alpha val="10000"/>
               </a:srgbClr>
             </a:outerShdw>
           </a:effectLst>
         </p:spPr>
+        <p:txBody>
+          <a:bodyPr/>
+          <a:lstStyle/>
+          <a:p>
+            <a:endParaRPr lang="en-US"/>
+          </a:p>
+        </p:txBody>
       </p:sp>
       <p:sp>
         <p:nvSpPr>
@@ -2028,7 +1571,7 @@
           <a:bodyPr wrap="square" rtlCol="0" anchor="ctr"/>
           <a:lstStyle/>
           <a:p>
-            <a:pPr algn="l" indent="0" marL="0">
+            <a:pPr marL="0" indent="0" algn="l">
               <a:buNone/>
             </a:pPr>
             <a:r>
@@ -2064,7 +1607,7 @@
           <a:bodyPr wrap="square" rtlCol="0" anchor="ctr"/>
           <a:lstStyle/>
           <a:p>
-            <a:pPr algn="l" indent="0" marL="0">
+            <a:pPr marL="0" indent="0" algn="l">
               <a:buNone/>
             </a:pPr>
             <a:r>
@@ -2103,7 +1646,7 @@
           <a:bodyPr wrap="square" rtlCol="0" anchor="ctr"/>
           <a:lstStyle/>
           <a:p>
-            <a:pPr algn="l" indent="0" marL="0">
+            <a:pPr marL="0" indent="0" algn="l">
               <a:buNone/>
             </a:pPr>
             <a:r>
@@ -2147,13 +1690,20 @@
             <a:prstDash val="solid"/>
           </a:ln>
           <a:effectLst>
-            <a:outerShdw sx="100000" sy="100000" kx="0" ky="0" algn="bl" rotWithShape="0" blurRad="101600" dist="25400" dir="2700000">
+            <a:outerShdw blurRad="101600" dist="25400" dir="2700000" algn="bl" rotWithShape="0">
               <a:srgbClr val="000000">
                 <a:alpha val="10000"/>
               </a:srgbClr>
             </a:outerShdw>
           </a:effectLst>
         </p:spPr>
+        <p:txBody>
+          <a:bodyPr/>
+          <a:lstStyle/>
+          <a:p>
+            <a:endParaRPr lang="en-US"/>
+          </a:p>
+        </p:txBody>
       </p:sp>
       <p:sp>
         <p:nvSpPr>
@@ -2176,7 +1726,7 @@
           <a:bodyPr wrap="square" rtlCol="0" anchor="ctr"/>
           <a:lstStyle/>
           <a:p>
-            <a:pPr algn="l" indent="0" marL="0">
+            <a:pPr marL="0" indent="0" algn="l">
               <a:buNone/>
             </a:pPr>
             <a:r>
@@ -2212,7 +1762,7 @@
           <a:bodyPr wrap="square" rtlCol="0" anchor="ctr"/>
           <a:lstStyle/>
           <a:p>
-            <a:pPr algn="l" indent="0" marL="0">
+            <a:pPr marL="0" indent="0" algn="l">
               <a:buNone/>
             </a:pPr>
             <a:r>
@@ -2251,7 +1801,7 @@
           <a:bodyPr wrap="square" rtlCol="0" anchor="ctr"/>
           <a:lstStyle/>
           <a:p>
-            <a:pPr algn="l" indent="0" marL="0">
+            <a:pPr marL="0" indent="0" algn="l">
               <a:buNone/>
             </a:pPr>
             <a:r>
@@ -2285,6 +1835,7 @@
         <a:solidFill>
           <a:srgbClr val="0F172A"/>
         </a:solidFill>
+        <a:effectLst/>
       </p:bgPr>
     </p:bg>
     <p:spTree>
@@ -2322,7 +1873,7 @@
           <a:bodyPr wrap="square" rtlCol="0" anchor="ctr"/>
           <a:lstStyle/>
           <a:p>
-            <a:pPr algn="l" indent="0" marL="0">
+            <a:pPr marL="0" indent="0" algn="l">
               <a:buNone/>
             </a:pPr>
             <a:r>
@@ -2366,6 +1917,13 @@
             <a:prstDash val="solid"/>
           </a:ln>
         </p:spPr>
+        <p:txBody>
+          <a:bodyPr/>
+          <a:lstStyle/>
+          <a:p>
+            <a:endParaRPr lang="en-US"/>
+          </a:p>
+        </p:txBody>
       </p:sp>
       <p:sp>
         <p:nvSpPr>
@@ -2388,7 +1946,7 @@
           <a:bodyPr wrap="square" rtlCol="0" anchor="ctr"/>
           <a:lstStyle/>
           <a:p>
-            <a:pPr algn="ctr" indent="0" marL="0">
+            <a:pPr marL="0" indent="0" algn="ctr">
               <a:buNone/>
             </a:pPr>
             <a:r>
@@ -2399,9 +1957,6 @@
               </a:rPr>
               <a:t>"</a:t>
             </a:r>
-            <a:pPr algn="ctr" indent="0" marL="0">
-              <a:buNone/>
-            </a:pPr>
             <a:r>
               <a:rPr lang="en-US" sz="2200" i="1" dirty="0">
                 <a:solidFill>
@@ -2410,9 +1965,6 @@
               </a:rPr>
               <a:t>spent $12 on lunch at McDonald's yesterday</a:t>
             </a:r>
-            <a:pPr algn="ctr" indent="0" marL="0">
-              <a:buNone/>
-            </a:pPr>
             <a:r>
               <a:rPr lang="en-US" sz="4000" b="1" dirty="0">
                 <a:solidFill>
@@ -2449,6 +2001,13 @@
             <a:prstDash val="solid"/>
           </a:ln>
         </p:spPr>
+        <p:txBody>
+          <a:bodyPr/>
+          <a:lstStyle/>
+          <a:p>
+            <a:endParaRPr lang="en-US"/>
+          </a:p>
+        </p:txBody>
       </p:sp>
       <p:sp>
         <p:nvSpPr>
@@ -2471,7 +2030,7 @@
           <a:bodyPr wrap="square" rtlCol="0" anchor="ctr"/>
           <a:lstStyle/>
           <a:p>
-            <a:pPr algn="ctr" indent="0" marL="0">
+            <a:pPr marL="0" indent="0" algn="ctr">
               <a:buNone/>
             </a:pPr>
             <a:r>
@@ -2510,7 +2069,7 @@
           <a:bodyPr wrap="square" rtlCol="0" anchor="ctr"/>
           <a:lstStyle/>
           <a:p>
-            <a:pPr algn="l" indent="0" marL="0">
+            <a:pPr marL="0" indent="0" algn="l">
               <a:buNone/>
             </a:pPr>
             <a:r>
@@ -2549,7 +2108,7 @@
           <a:bodyPr wrap="square" rtlCol="0" anchor="ctr"/>
           <a:lstStyle/>
           <a:p>
-            <a:pPr algn="l" indent="0" marL="0">
+            <a:pPr marL="0" indent="0" algn="l">
               <a:buNone/>
             </a:pPr>
             <a:r>
@@ -2591,6 +2150,13 @@
             <a:prstDash val="solid"/>
           </a:ln>
         </p:spPr>
+        <p:txBody>
+          <a:bodyPr/>
+          <a:lstStyle/>
+          <a:p>
+            <a:endParaRPr lang="en-US"/>
+          </a:p>
+        </p:txBody>
       </p:sp>
       <p:sp>
         <p:nvSpPr>
@@ -2613,7 +2179,7 @@
           <a:bodyPr wrap="square" rtlCol="0" anchor="ctr"/>
           <a:lstStyle/>
           <a:p>
-            <a:pPr algn="ctr" indent="0" marL="0">
+            <a:pPr marL="0" indent="0" algn="ctr">
               <a:buNone/>
             </a:pPr>
             <a:r>
@@ -2652,7 +2218,7 @@
           <a:bodyPr wrap="square" rtlCol="0" anchor="ctr"/>
           <a:lstStyle/>
           <a:p>
-            <a:pPr algn="l" indent="0" marL="0">
+            <a:pPr marL="0" indent="0" algn="l">
               <a:buNone/>
             </a:pPr>
             <a:r>
@@ -2691,7 +2257,7 @@
           <a:bodyPr wrap="square" rtlCol="0" anchor="ctr"/>
           <a:lstStyle/>
           <a:p>
-            <a:pPr algn="l" indent="0" marL="0">
+            <a:pPr marL="0" indent="0" algn="l">
               <a:buNone/>
             </a:pPr>
             <a:r>
@@ -2733,6 +2299,13 @@
             <a:prstDash val="solid"/>
           </a:ln>
         </p:spPr>
+        <p:txBody>
+          <a:bodyPr/>
+          <a:lstStyle/>
+          <a:p>
+            <a:endParaRPr lang="en-US"/>
+          </a:p>
+        </p:txBody>
       </p:sp>
       <p:sp>
         <p:nvSpPr>
@@ -2755,7 +2328,7 @@
           <a:bodyPr wrap="square" rtlCol="0" anchor="ctr"/>
           <a:lstStyle/>
           <a:p>
-            <a:pPr algn="ctr" indent="0" marL="0">
+            <a:pPr marL="0" indent="0" algn="ctr">
               <a:buNone/>
             </a:pPr>
             <a:r>
@@ -2794,7 +2367,7 @@
           <a:bodyPr wrap="square" rtlCol="0" anchor="ctr"/>
           <a:lstStyle/>
           <a:p>
-            <a:pPr algn="l" indent="0" marL="0">
+            <a:pPr marL="0" indent="0" algn="l">
               <a:buNone/>
             </a:pPr>
             <a:r>
@@ -2833,7 +2406,7 @@
           <a:bodyPr wrap="square" rtlCol="0" anchor="ctr"/>
           <a:lstStyle/>
           <a:p>
-            <a:pPr algn="l" indent="0" marL="0">
+            <a:pPr marL="0" indent="0" algn="l">
               <a:buNone/>
             </a:pPr>
             <a:r>
@@ -2867,6 +2440,7 @@
         <a:solidFill>
           <a:srgbClr val="FFFFFF"/>
         </a:solidFill>
+        <a:effectLst/>
       </p:bgPr>
     </p:bg>
     <p:spTree>
@@ -2904,7 +2478,7 @@
           <a:bodyPr wrap="square" rtlCol="0" anchor="ctr"/>
           <a:lstStyle/>
           <a:p>
-            <a:pPr algn="l" indent="0" marL="0">
+            <a:pPr marL="0" indent="0" algn="l">
               <a:buNone/>
             </a:pPr>
             <a:r>
@@ -2948,13 +2522,20 @@
             <a:prstDash val="solid"/>
           </a:ln>
           <a:effectLst>
-            <a:outerShdw sx="100000" sy="100000" kx="0" ky="0" algn="bl" rotWithShape="0" blurRad="101600" dist="25400" dir="2700000">
+            <a:outerShdw blurRad="101600" dist="25400" dir="2700000" algn="bl" rotWithShape="0">
               <a:srgbClr val="000000">
                 <a:alpha val="10000"/>
               </a:srgbClr>
             </a:outerShdw>
           </a:effectLst>
         </p:spPr>
+        <p:txBody>
+          <a:bodyPr/>
+          <a:lstStyle/>
+          <a:p>
+            <a:endParaRPr lang="en-US"/>
+          </a:p>
+        </p:txBody>
       </p:sp>
       <p:sp>
         <p:nvSpPr>
@@ -2977,7 +2558,7 @@
           <a:bodyPr wrap="square" rtlCol="0" anchor="ctr"/>
           <a:lstStyle/>
           <a:p>
-            <a:pPr indent="0" marL="0">
+            <a:pPr marL="0" indent="0">
               <a:buNone/>
             </a:pPr>
             <a:r>
@@ -3013,7 +2594,7 @@
           <a:bodyPr wrap="square" rtlCol="0" anchor="ctr"/>
           <a:lstStyle/>
           <a:p>
-            <a:pPr algn="l" indent="0" marL="0">
+            <a:pPr marL="0" indent="0" algn="l">
               <a:buNone/>
             </a:pPr>
             <a:r>
@@ -3052,7 +2633,7 @@
           <a:bodyPr wrap="square" rtlCol="0" anchor="ctr"/>
           <a:lstStyle/>
           <a:p>
-            <a:pPr algn="l" indent="0" marL="0">
+            <a:pPr marL="0" indent="0" algn="l">
               <a:buNone/>
             </a:pPr>
             <a:r>
@@ -3096,13 +2677,20 @@
             <a:prstDash val="solid"/>
           </a:ln>
           <a:effectLst>
-            <a:outerShdw sx="100000" sy="100000" kx="0" ky="0" algn="bl" rotWithShape="0" blurRad="101600" dist="25400" dir="2700000">
+            <a:outerShdw blurRad="101600" dist="25400" dir="2700000" algn="bl" rotWithShape="0">
               <a:srgbClr val="000000">
                 <a:alpha val="10000"/>
               </a:srgbClr>
             </a:outerShdw>
           </a:effectLst>
         </p:spPr>
+        <p:txBody>
+          <a:bodyPr/>
+          <a:lstStyle/>
+          <a:p>
+            <a:endParaRPr lang="en-US"/>
+          </a:p>
+        </p:txBody>
       </p:sp>
       <p:sp>
         <p:nvSpPr>
@@ -3125,7 +2713,7 @@
           <a:bodyPr wrap="square" rtlCol="0" anchor="ctr"/>
           <a:lstStyle/>
           <a:p>
-            <a:pPr indent="0" marL="0">
+            <a:pPr marL="0" indent="0">
               <a:buNone/>
             </a:pPr>
             <a:r>
@@ -3161,7 +2749,7 @@
           <a:bodyPr wrap="square" rtlCol="0" anchor="ctr"/>
           <a:lstStyle/>
           <a:p>
-            <a:pPr algn="l" indent="0" marL="0">
+            <a:pPr marL="0" indent="0" algn="l">
               <a:buNone/>
             </a:pPr>
             <a:r>
@@ -3200,7 +2788,7 @@
           <a:bodyPr wrap="square" rtlCol="0" anchor="ctr"/>
           <a:lstStyle/>
           <a:p>
-            <a:pPr algn="l" indent="0" marL="0">
+            <a:pPr marL="0" indent="0" algn="l">
               <a:buNone/>
             </a:pPr>
             <a:r>
@@ -3244,13 +2832,20 @@
             <a:prstDash val="solid"/>
           </a:ln>
           <a:effectLst>
-            <a:outerShdw sx="100000" sy="100000" kx="0" ky="0" algn="bl" rotWithShape="0" blurRad="101600" dist="25400" dir="2700000">
+            <a:outerShdw blurRad="101600" dist="25400" dir="2700000" algn="bl" rotWithShape="0">
               <a:srgbClr val="000000">
                 <a:alpha val="10000"/>
               </a:srgbClr>
             </a:outerShdw>
           </a:effectLst>
         </p:spPr>
+        <p:txBody>
+          <a:bodyPr/>
+          <a:lstStyle/>
+          <a:p>
+            <a:endParaRPr lang="en-US"/>
+          </a:p>
+        </p:txBody>
       </p:sp>
       <p:sp>
         <p:nvSpPr>
@@ -3273,7 +2868,7 @@
           <a:bodyPr wrap="square" rtlCol="0" anchor="ctr"/>
           <a:lstStyle/>
           <a:p>
-            <a:pPr indent="0" marL="0">
+            <a:pPr marL="0" indent="0">
               <a:buNone/>
             </a:pPr>
             <a:r>
@@ -3309,7 +2904,7 @@
           <a:bodyPr wrap="square" rtlCol="0" anchor="ctr"/>
           <a:lstStyle/>
           <a:p>
-            <a:pPr algn="l" indent="0" marL="0">
+            <a:pPr marL="0" indent="0" algn="l">
               <a:buNone/>
             </a:pPr>
             <a:r>
@@ -3348,7 +2943,7 @@
           <a:bodyPr wrap="square" rtlCol="0" anchor="ctr"/>
           <a:lstStyle/>
           <a:p>
-            <a:pPr algn="l" indent="0" marL="0">
+            <a:pPr marL="0" indent="0" algn="l">
               <a:buNone/>
             </a:pPr>
             <a:r>
@@ -3382,6 +2977,7 @@
         <a:solidFill>
           <a:srgbClr val="F8FAFC"/>
         </a:solidFill>
+        <a:effectLst/>
       </p:bgPr>
     </p:bg>
     <p:spTree>
@@ -3419,7 +3015,7 @@
           <a:bodyPr wrap="square" rtlCol="0" anchor="ctr"/>
           <a:lstStyle/>
           <a:p>
-            <a:pPr algn="l" indent="0" marL="0">
+            <a:pPr marL="0" indent="0" algn="l">
               <a:buNone/>
             </a:pPr>
             <a:r>
@@ -3439,17 +3035,17 @@
       </p:sp>
       <p:pic>
         <p:nvPicPr>
-          <p:cNvPr id="3" name="Image 0" descr="/Users/lionellam/Documents/DevelopmentWork/hercules/Project Hercules - Log an Expense Flow.svg">    </p:cNvPr>
+          <p:cNvPr id="3" name="Image 0" descr="/Users/lionellam/Documents/DevelopmentWork/hercules/Project Hercules - Log an Expense Flow.svg"/>
           <p:cNvPicPr>
             <a:picLocks noChangeAspect="1"/>
           </p:cNvPicPr>
           <p:nvPr/>
         </p:nvPicPr>
         <p:blipFill>
-          <a:blip r:embed="rId1">
+          <a:blip>
             <a:extLst>
               <a:ext uri="{96DAC541-7B7A-43D3-8B79-37D633B846F1}">
-                <asvg:svgBlip xmlns:asvg="http://schemas.microsoft.com/office/drawing/2016/SVG/main" r:embed="rId2"/>
+                <asvg:svgBlip xmlns:asvg="http://schemas.microsoft.com/office/drawing/2016/SVG/main" r:embed="rId3"/>
               </a:ext>
             </a:extLst>
           </a:blip>
@@ -3483,6 +3079,7 @@
         <a:solidFill>
           <a:srgbClr val="FFFFFF"/>
         </a:solidFill>
+        <a:effectLst/>
       </p:bgPr>
     </p:bg>
     <p:spTree>
@@ -3520,7 +3117,7 @@
           <a:bodyPr wrap="square" rtlCol="0" anchor="ctr"/>
           <a:lstStyle/>
           <a:p>
-            <a:pPr algn="l" indent="0" marL="0">
+            <a:pPr marL="0" indent="0" algn="l">
               <a:buNone/>
             </a:pPr>
             <a:r>
@@ -3564,13 +3161,20 @@
             <a:prstDash val="solid"/>
           </a:ln>
           <a:effectLst>
-            <a:outerShdw sx="100000" sy="100000" kx="0" ky="0" algn="bl" rotWithShape="0" blurRad="101600" dist="25400" dir="2700000">
+            <a:outerShdw blurRad="101600" dist="25400" dir="2700000" algn="bl" rotWithShape="0">
               <a:srgbClr val="000000">
                 <a:alpha val="10000"/>
               </a:srgbClr>
             </a:outerShdw>
           </a:effectLst>
         </p:spPr>
+        <p:txBody>
+          <a:bodyPr/>
+          <a:lstStyle/>
+          <a:p>
+            <a:endParaRPr lang="en-US"/>
+          </a:p>
+        </p:txBody>
       </p:sp>
       <p:sp>
         <p:nvSpPr>
@@ -3596,6 +3200,13 @@
             <a:prstDash val="solid"/>
           </a:ln>
         </p:spPr>
+        <p:txBody>
+          <a:bodyPr/>
+          <a:lstStyle/>
+          <a:p>
+            <a:endParaRPr lang="en-US"/>
+          </a:p>
+        </p:txBody>
       </p:sp>
       <p:sp>
         <p:nvSpPr>
@@ -3618,7 +3229,7 @@
           <a:bodyPr wrap="square" rtlCol="0" anchor="ctr"/>
           <a:lstStyle/>
           <a:p>
-            <a:pPr algn="ctr" indent="0" marL="0">
+            <a:pPr marL="0" indent="0" algn="ctr">
               <a:buNone/>
             </a:pPr>
             <a:r>
@@ -3657,7 +3268,7 @@
           <a:bodyPr wrap="square" rtlCol="0" anchor="ctr"/>
           <a:lstStyle/>
           <a:p>
-            <a:pPr algn="ctr" indent="0" marL="0">
+            <a:pPr marL="0" indent="0" algn="ctr">
               <a:buNone/>
             </a:pPr>
             <a:r>
@@ -3696,7 +3307,7 @@
           <a:bodyPr wrap="square" rtlCol="0" anchor="ctr"/>
           <a:lstStyle/>
           <a:p>
-            <a:pPr algn="ctr" indent="0" marL="0">
+            <a:pPr marL="0" indent="0" algn="ctr">
               <a:buNone/>
             </a:pPr>
             <a:r>
@@ -3735,7 +3346,7 @@
           <a:bodyPr wrap="square" rtlCol="0" anchor="ctr"/>
           <a:lstStyle/>
           <a:p>
-            <a:pPr algn="l" indent="0" marL="0">
+            <a:pPr marL="0" indent="0" algn="l">
               <a:buNone/>
             </a:pPr>
             <a:r>
@@ -3779,13 +3390,20 @@
             <a:prstDash val="solid"/>
           </a:ln>
           <a:effectLst>
-            <a:outerShdw sx="100000" sy="100000" kx="0" ky="0" algn="bl" rotWithShape="0" blurRad="101600" dist="25400" dir="2700000">
+            <a:outerShdw blurRad="101600" dist="25400" dir="2700000" algn="bl" rotWithShape="0">
               <a:srgbClr val="000000">
                 <a:alpha val="10000"/>
               </a:srgbClr>
             </a:outerShdw>
           </a:effectLst>
         </p:spPr>
+        <p:txBody>
+          <a:bodyPr/>
+          <a:lstStyle/>
+          <a:p>
+            <a:endParaRPr lang="en-US"/>
+          </a:p>
+        </p:txBody>
       </p:sp>
       <p:sp>
         <p:nvSpPr>
@@ -3811,6 +3429,13 @@
             <a:prstDash val="solid"/>
           </a:ln>
         </p:spPr>
+        <p:txBody>
+          <a:bodyPr/>
+          <a:lstStyle/>
+          <a:p>
+            <a:endParaRPr lang="en-US"/>
+          </a:p>
+        </p:txBody>
       </p:sp>
       <p:sp>
         <p:nvSpPr>
@@ -3833,7 +3458,7 @@
           <a:bodyPr wrap="square" rtlCol="0" anchor="ctr"/>
           <a:lstStyle/>
           <a:p>
-            <a:pPr algn="ctr" indent="0" marL="0">
+            <a:pPr marL="0" indent="0" algn="ctr">
               <a:buNone/>
             </a:pPr>
             <a:r>
@@ -3872,7 +3497,7 @@
           <a:bodyPr wrap="square" rtlCol="0" anchor="ctr"/>
           <a:lstStyle/>
           <a:p>
-            <a:pPr algn="ctr" indent="0" marL="0">
+            <a:pPr marL="0" indent="0" algn="ctr">
               <a:buNone/>
             </a:pPr>
             <a:r>
@@ -3911,7 +3536,7 @@
           <a:bodyPr wrap="square" rtlCol="0" anchor="ctr"/>
           <a:lstStyle/>
           <a:p>
-            <a:pPr algn="ctr" indent="0" marL="0">
+            <a:pPr marL="0" indent="0" algn="ctr">
               <a:buNone/>
             </a:pPr>
             <a:r>
@@ -3950,7 +3575,7 @@
           <a:bodyPr wrap="square" rtlCol="0" anchor="ctr"/>
           <a:lstStyle/>
           <a:p>
-            <a:pPr algn="l" indent="0" marL="0">
+            <a:pPr marL="0" indent="0" algn="l">
               <a:buNone/>
             </a:pPr>
             <a:r>
@@ -3994,13 +3619,20 @@
             <a:prstDash val="solid"/>
           </a:ln>
           <a:effectLst>
-            <a:outerShdw sx="100000" sy="100000" kx="0" ky="0" algn="bl" rotWithShape="0" blurRad="101600" dist="25400" dir="2700000">
+            <a:outerShdw blurRad="101600" dist="25400" dir="2700000" algn="bl" rotWithShape="0">
               <a:srgbClr val="000000">
                 <a:alpha val="10000"/>
               </a:srgbClr>
             </a:outerShdw>
           </a:effectLst>
         </p:spPr>
+        <p:txBody>
+          <a:bodyPr/>
+          <a:lstStyle/>
+          <a:p>
+            <a:endParaRPr lang="en-US"/>
+          </a:p>
+        </p:txBody>
       </p:sp>
       <p:sp>
         <p:nvSpPr>
@@ -4026,6 +3658,13 @@
             <a:prstDash val="solid"/>
           </a:ln>
         </p:spPr>
+        <p:txBody>
+          <a:bodyPr/>
+          <a:lstStyle/>
+          <a:p>
+            <a:endParaRPr lang="en-US"/>
+          </a:p>
+        </p:txBody>
       </p:sp>
       <p:sp>
         <p:nvSpPr>
@@ -4048,7 +3687,7 @@
           <a:bodyPr wrap="square" rtlCol="0" anchor="ctr"/>
           <a:lstStyle/>
           <a:p>
-            <a:pPr algn="ctr" indent="0" marL="0">
+            <a:pPr marL="0" indent="0" algn="ctr">
               <a:buNone/>
             </a:pPr>
             <a:r>
@@ -4087,7 +3726,7 @@
           <a:bodyPr wrap="square" rtlCol="0" anchor="ctr"/>
           <a:lstStyle/>
           <a:p>
-            <a:pPr algn="ctr" indent="0" marL="0">
+            <a:pPr marL="0" indent="0" algn="ctr">
               <a:buNone/>
             </a:pPr>
             <a:r>
@@ -4126,7 +3765,7 @@
           <a:bodyPr wrap="square" rtlCol="0" anchor="ctr"/>
           <a:lstStyle/>
           <a:p>
-            <a:pPr algn="ctr" indent="0" marL="0">
+            <a:pPr marL="0" indent="0" algn="ctr">
               <a:buNone/>
             </a:pPr>
             <a:r>
@@ -4165,7 +3804,7 @@
           <a:bodyPr wrap="square" rtlCol="0" anchor="ctr"/>
           <a:lstStyle/>
           <a:p>
-            <a:pPr algn="l" indent="0" marL="0">
+            <a:pPr marL="0" indent="0" algn="l">
               <a:buNone/>
             </a:pPr>
             <a:r>
@@ -4209,13 +3848,20 @@
             <a:prstDash val="solid"/>
           </a:ln>
           <a:effectLst>
-            <a:outerShdw sx="100000" sy="100000" kx="0" ky="0" algn="bl" rotWithShape="0" blurRad="101600" dist="25400" dir="2700000">
+            <a:outerShdw blurRad="101600" dist="25400" dir="2700000" algn="bl" rotWithShape="0">
               <a:srgbClr val="000000">
                 <a:alpha val="10000"/>
               </a:srgbClr>
             </a:outerShdw>
           </a:effectLst>
         </p:spPr>
+        <p:txBody>
+          <a:bodyPr/>
+          <a:lstStyle/>
+          <a:p>
+            <a:endParaRPr lang="en-US"/>
+          </a:p>
+        </p:txBody>
       </p:sp>
       <p:sp>
         <p:nvSpPr>
@@ -4241,6 +3887,13 @@
             <a:prstDash val="solid"/>
           </a:ln>
         </p:spPr>
+        <p:txBody>
+          <a:bodyPr/>
+          <a:lstStyle/>
+          <a:p>
+            <a:endParaRPr lang="en-US"/>
+          </a:p>
+        </p:txBody>
       </p:sp>
       <p:sp>
         <p:nvSpPr>
@@ -4263,7 +3916,7 @@
           <a:bodyPr wrap="square" rtlCol="0" anchor="ctr"/>
           <a:lstStyle/>
           <a:p>
-            <a:pPr algn="ctr" indent="0" marL="0">
+            <a:pPr marL="0" indent="0" algn="ctr">
               <a:buNone/>
             </a:pPr>
             <a:r>
@@ -4302,7 +3955,7 @@
           <a:bodyPr wrap="square" rtlCol="0" anchor="ctr"/>
           <a:lstStyle/>
           <a:p>
-            <a:pPr algn="ctr" indent="0" marL="0">
+            <a:pPr marL="0" indent="0" algn="ctr">
               <a:buNone/>
             </a:pPr>
             <a:r>
@@ -4341,7 +3994,7 @@
           <a:bodyPr wrap="square" rtlCol="0" anchor="ctr"/>
           <a:lstStyle/>
           <a:p>
-            <a:pPr algn="ctr" indent="0" marL="0">
+            <a:pPr marL="0" indent="0" algn="ctr">
               <a:buNone/>
             </a:pPr>
             <a:r>
@@ -4380,7 +4033,7 @@
           <a:bodyPr wrap="square" rtlCol="0" anchor="ctr"/>
           <a:lstStyle/>
           <a:p>
-            <a:pPr algn="l" indent="0" marL="0">
+            <a:pPr marL="0" indent="0" algn="l">
               <a:buNone/>
             </a:pPr>
             <a:r>
@@ -4419,7 +4072,7 @@
           <a:bodyPr wrap="square" rtlCol="0" anchor="ctr"/>
           <a:lstStyle/>
           <a:p>
-            <a:pPr algn="ctr" indent="0" marL="0">
+            <a:pPr marL="0" indent="0" algn="ctr">
               <a:buNone/>
             </a:pPr>
             <a:r>
@@ -4434,1561 +4087,6 @@
               <a:t>Phases are sequential and iterative. Exact timelines TBD as the project progresses.</a:t>
             </a:r>
             <a:endParaRPr lang="en-US" sz="1000" dirty="0"/>
-          </a:p>
-        </p:txBody>
-      </p:sp>
-    </p:spTree>
-  </p:cSld>
-  <p:clrMapOvr>
-    <a:masterClrMapping/>
-  </p:clrMapOvr>
-</p:sld>
-</file>
-
-<file path=ppt/slides/slide7.xml><?xml version="1.0" encoding="utf-8"?>
-<p:sld xmlns:a="http://schemas.openxmlformats.org/drawingml/2006/main" xmlns:r="http://schemas.openxmlformats.org/officeDocument/2006/relationships" xmlns:p="http://schemas.openxmlformats.org/presentationml/2006/main">
-  <p:cSld name="Slide 7">
-    <p:bg>
-      <p:bgPr>
-        <a:solidFill>
-          <a:srgbClr val="0F172A"/>
-        </a:solidFill>
-      </p:bgPr>
-    </p:bg>
-    <p:spTree>
-      <p:nvGrpSpPr>
-        <p:cNvPr id="1" name=""/>
-        <p:cNvGrpSpPr/>
-        <p:nvPr/>
-      </p:nvGrpSpPr>
-      <p:grpSpPr>
-        <a:xfrm>
-          <a:off x="0" y="0"/>
-          <a:ext cx="0" cy="0"/>
-          <a:chOff x="0" y="0"/>
-          <a:chExt cx="0" cy="0"/>
-        </a:xfrm>
-      </p:grpSpPr>
-      <p:sp>
-        <p:nvSpPr>
-          <p:cNvPr id="2" name="Text 0"/>
-          <p:cNvSpPr/>
-          <p:nvPr/>
-        </p:nvSpPr>
-        <p:spPr>
-          <a:xfrm>
-            <a:off x="548640" y="320040"/>
-            <a:ext cx="8046720" cy="594360"/>
-          </a:xfrm>
-          <a:prstGeom prst="rect">
-            <a:avLst/>
-          </a:prstGeom>
-          <a:noFill/>
-          <a:ln/>
-        </p:spPr>
-        <p:txBody>
-          <a:bodyPr wrap="square" rtlCol="0" anchor="ctr"/>
-          <a:lstStyle/>
-          <a:p>
-            <a:pPr algn="l" indent="0" marL="0">
-              <a:buNone/>
-            </a:pPr>
-            <a:r>
-              <a:rPr lang="en-US" sz="3200" b="1" dirty="0">
-                <a:solidFill>
-                  <a:srgbClr val="FFFFFF"/>
-                </a:solidFill>
-                <a:latin typeface="Cambria" pitchFamily="34" charset="0"/>
-                <a:ea typeface="Cambria" pitchFamily="34" charset="-122"/>
-                <a:cs typeface="Cambria" pitchFamily="34" charset="-120"/>
-              </a:rPr>
-              <a:t>Success Criteria</a:t>
-            </a:r>
-            <a:endParaRPr lang="en-US" sz="3200" dirty="0"/>
-          </a:p>
-        </p:txBody>
-      </p:sp>
-      <p:sp>
-        <p:nvSpPr>
-          <p:cNvPr id="3" name="Shape 1"/>
-          <p:cNvSpPr/>
-          <p:nvPr/>
-        </p:nvSpPr>
-        <p:spPr>
-          <a:xfrm>
-            <a:off x="457200" y="1097280"/>
-            <a:ext cx="2606040" cy="3291840"/>
-          </a:xfrm>
-          <a:prstGeom prst="roundRect">
-            <a:avLst>
-              <a:gd name="adj" fmla="val 4211"/>
-            </a:avLst>
-          </a:prstGeom>
-          <a:solidFill>
-            <a:srgbClr val="1E293B"/>
-          </a:solidFill>
-          <a:ln w="12700">
-            <a:solidFill>
-              <a:srgbClr val="334155"/>
-            </a:solidFill>
-            <a:prstDash val="solid"/>
-          </a:ln>
-          <a:effectLst>
-            <a:outerShdw sx="100000" sy="100000" kx="0" ky="0" algn="bl" rotWithShape="0" blurRad="101600" dist="25400" dir="2700000">
-              <a:srgbClr val="000000">
-                <a:alpha val="10000"/>
-              </a:srgbClr>
-            </a:outerShdw>
-          </a:effectLst>
-        </p:spPr>
-      </p:sp>
-      <p:sp>
-        <p:nvSpPr>
-          <p:cNvPr id="4" name="Text 2"/>
-          <p:cNvSpPr/>
-          <p:nvPr/>
-        </p:nvSpPr>
-        <p:spPr>
-          <a:xfrm>
-            <a:off x="548640" y="1463040"/>
-            <a:ext cx="2423160" cy="1005840"/>
-          </a:xfrm>
-          <a:prstGeom prst="rect">
-            <a:avLst/>
-          </a:prstGeom>
-          <a:noFill/>
-          <a:ln/>
-        </p:spPr>
-        <p:txBody>
-          <a:bodyPr wrap="square" rtlCol="0" anchor="ctr"/>
-          <a:lstStyle/>
-          <a:p>
-            <a:pPr algn="ctr" indent="0" marL="0">
-              <a:buNone/>
-            </a:pPr>
-            <a:r>
-              <a:rPr lang="en-US" sz="5200" b="1" dirty="0">
-                <a:solidFill>
-                  <a:srgbClr val="D97706"/>
-                </a:solidFill>
-                <a:latin typeface="Cambria" pitchFamily="34" charset="0"/>
-                <a:ea typeface="Cambria" pitchFamily="34" charset="-122"/>
-                <a:cs typeface="Cambria" pitchFamily="34" charset="-120"/>
-              </a:rPr>
-              <a:t>&lt; 30s</a:t>
-            </a:r>
-            <a:endParaRPr lang="en-US" sz="5200" dirty="0"/>
-          </a:p>
-        </p:txBody>
-      </p:sp>
-      <p:sp>
-        <p:nvSpPr>
-          <p:cNvPr id="5" name="Text 3"/>
-          <p:cNvSpPr/>
-          <p:nvPr/>
-        </p:nvSpPr>
-        <p:spPr>
-          <a:xfrm>
-            <a:off x="594360" y="2606040"/>
-            <a:ext cx="2331720" cy="1554480"/>
-          </a:xfrm>
-          <a:prstGeom prst="rect">
-            <a:avLst/>
-          </a:prstGeom>
-          <a:noFill/>
-          <a:ln/>
-        </p:spPr>
-        <p:txBody>
-          <a:bodyPr wrap="square" rtlCol="0" anchor="ctr"/>
-          <a:lstStyle/>
-          <a:p>
-            <a:pPr algn="ctr" indent="0" marL="0">
-              <a:buNone/>
-            </a:pPr>
-            <a:r>
-              <a:rPr lang="en-US" sz="1300" dirty="0">
-                <a:solidFill>
-                  <a:srgbClr val="94A3B8"/>
-                </a:solidFill>
-                <a:latin typeface="Calibri" pitchFamily="34" charset="0"/>
-                <a:ea typeface="Calibri" pitchFamily="34" charset="-122"/>
-                <a:cs typeface="Calibri" pitchFamily="34" charset="-120"/>
-              </a:rPr>
-              <a:t>to log a full day's expenses via natural language</a:t>
-            </a:r>
-            <a:endParaRPr lang="en-US" sz="1300" dirty="0"/>
-          </a:p>
-        </p:txBody>
-      </p:sp>
-      <p:sp>
-        <p:nvSpPr>
-          <p:cNvPr id="6" name="Shape 4"/>
-          <p:cNvSpPr/>
-          <p:nvPr/>
-        </p:nvSpPr>
-        <p:spPr>
-          <a:xfrm>
-            <a:off x="3291840" y="1097280"/>
-            <a:ext cx="2606040" cy="3291840"/>
-          </a:xfrm>
-          <a:prstGeom prst="roundRect">
-            <a:avLst>
-              <a:gd name="adj" fmla="val 4211"/>
-            </a:avLst>
-          </a:prstGeom>
-          <a:solidFill>
-            <a:srgbClr val="1E293B"/>
-          </a:solidFill>
-          <a:ln w="12700">
-            <a:solidFill>
-              <a:srgbClr val="334155"/>
-            </a:solidFill>
-            <a:prstDash val="solid"/>
-          </a:ln>
-          <a:effectLst>
-            <a:outerShdw sx="100000" sy="100000" kx="0" ky="0" algn="bl" rotWithShape="0" blurRad="101600" dist="25400" dir="2700000">
-              <a:srgbClr val="000000">
-                <a:alpha val="10000"/>
-              </a:srgbClr>
-            </a:outerShdw>
-          </a:effectLst>
-        </p:spPr>
-      </p:sp>
-      <p:sp>
-        <p:nvSpPr>
-          <p:cNvPr id="7" name="Text 5"/>
-          <p:cNvSpPr/>
-          <p:nvPr/>
-        </p:nvSpPr>
-        <p:spPr>
-          <a:xfrm>
-            <a:off x="3383280" y="1463040"/>
-            <a:ext cx="2423160" cy="1005840"/>
-          </a:xfrm>
-          <a:prstGeom prst="rect">
-            <a:avLst/>
-          </a:prstGeom>
-          <a:noFill/>
-          <a:ln/>
-        </p:spPr>
-        <p:txBody>
-          <a:bodyPr wrap="square" rtlCol="0" anchor="ctr"/>
-          <a:lstStyle/>
-          <a:p>
-            <a:pPr algn="ctr" indent="0" marL="0">
-              <a:buNone/>
-            </a:pPr>
-            <a:r>
-              <a:rPr lang="en-US" sz="5200" b="1" dirty="0">
-                <a:solidFill>
-                  <a:srgbClr val="D97706"/>
-                </a:solidFill>
-                <a:latin typeface="Cambria" pitchFamily="34" charset="0"/>
-                <a:ea typeface="Cambria" pitchFamily="34" charset="-122"/>
-                <a:cs typeface="Cambria" pitchFamily="34" charset="-120"/>
-              </a:rPr>
-              <a:t>&lt; 10%</a:t>
-            </a:r>
-            <a:endParaRPr lang="en-US" sz="5200" dirty="0"/>
-          </a:p>
-        </p:txBody>
-      </p:sp>
-      <p:sp>
-        <p:nvSpPr>
-          <p:cNvPr id="8" name="Text 6"/>
-          <p:cNvSpPr/>
-          <p:nvPr/>
-        </p:nvSpPr>
-        <p:spPr>
-          <a:xfrm>
-            <a:off x="3429000" y="2606040"/>
-            <a:ext cx="2331720" cy="1554480"/>
-          </a:xfrm>
-          <a:prstGeom prst="rect">
-            <a:avLst/>
-          </a:prstGeom>
-          <a:noFill/>
-          <a:ln/>
-        </p:spPr>
-        <p:txBody>
-          <a:bodyPr wrap="square" rtlCol="0" anchor="ctr"/>
-          <a:lstStyle/>
-          <a:p>
-            <a:pPr algn="ctr" indent="0" marL="0">
-              <a:buNone/>
-            </a:pPr>
-            <a:r>
-              <a:rPr lang="en-US" sz="1300" dirty="0">
-                <a:solidFill>
-                  <a:srgbClr val="94A3B8"/>
-                </a:solidFill>
-                <a:latin typeface="Calibri" pitchFamily="34" charset="0"/>
-                <a:ea typeface="Calibri" pitchFamily="34" charset="-122"/>
-                <a:cs typeface="Calibri" pitchFamily="34" charset="-120"/>
-              </a:rPr>
-              <a:t>of entries require manual correction after AI parsing</a:t>
-            </a:r>
-            <a:endParaRPr lang="en-US" sz="1300" dirty="0"/>
-          </a:p>
-        </p:txBody>
-      </p:sp>
-      <p:sp>
-        <p:nvSpPr>
-          <p:cNvPr id="9" name="Shape 7"/>
-          <p:cNvSpPr/>
-          <p:nvPr/>
-        </p:nvSpPr>
-        <p:spPr>
-          <a:xfrm>
-            <a:off x="6126480" y="1097280"/>
-            <a:ext cx="2606040" cy="3291840"/>
-          </a:xfrm>
-          <a:prstGeom prst="roundRect">
-            <a:avLst>
-              <a:gd name="adj" fmla="val 4211"/>
-            </a:avLst>
-          </a:prstGeom>
-          <a:solidFill>
-            <a:srgbClr val="1E293B"/>
-          </a:solidFill>
-          <a:ln w="12700">
-            <a:solidFill>
-              <a:srgbClr val="334155"/>
-            </a:solidFill>
-            <a:prstDash val="solid"/>
-          </a:ln>
-          <a:effectLst>
-            <a:outerShdw sx="100000" sy="100000" kx="0" ky="0" algn="bl" rotWithShape="0" blurRad="101600" dist="25400" dir="2700000">
-              <a:srgbClr val="000000">
-                <a:alpha val="10000"/>
-              </a:srgbClr>
-            </a:outerShdw>
-          </a:effectLst>
-        </p:spPr>
-      </p:sp>
-      <p:sp>
-        <p:nvSpPr>
-          <p:cNvPr id="10" name="Text 8"/>
-          <p:cNvSpPr/>
-          <p:nvPr/>
-        </p:nvSpPr>
-        <p:spPr>
-          <a:xfrm>
-            <a:off x="6217920" y="1463040"/>
-            <a:ext cx="2423160" cy="1005840"/>
-          </a:xfrm>
-          <a:prstGeom prst="rect">
-            <a:avLst/>
-          </a:prstGeom>
-          <a:noFill/>
-          <a:ln/>
-        </p:spPr>
-        <p:txBody>
-          <a:bodyPr wrap="square" rtlCol="0" anchor="ctr"/>
-          <a:lstStyle/>
-          <a:p>
-            <a:pPr algn="ctr" indent="0" marL="0">
-              <a:buNone/>
-            </a:pPr>
-            <a:r>
-              <a:rPr lang="en-US" sz="5200" b="1" dirty="0">
-                <a:solidFill>
-                  <a:srgbClr val="D97706"/>
-                </a:solidFill>
-                <a:latin typeface="Cambria" pitchFamily="34" charset="0"/>
-                <a:ea typeface="Cambria" pitchFamily="34" charset="-122"/>
-                <a:cs typeface="Cambria" pitchFamily="34" charset="-120"/>
-              </a:rPr>
-              <a:t>0</a:t>
-            </a:r>
-            <a:endParaRPr lang="en-US" sz="5200" dirty="0"/>
-          </a:p>
-        </p:txBody>
-      </p:sp>
-      <p:sp>
-        <p:nvSpPr>
-          <p:cNvPr id="11" name="Text 9"/>
-          <p:cNvSpPr/>
-          <p:nvPr/>
-        </p:nvSpPr>
-        <p:spPr>
-          <a:xfrm>
-            <a:off x="6263640" y="2606040"/>
-            <a:ext cx="2331720" cy="1554480"/>
-          </a:xfrm>
-          <a:prstGeom prst="rect">
-            <a:avLst/>
-          </a:prstGeom>
-          <a:noFill/>
-          <a:ln/>
-        </p:spPr>
-        <p:txBody>
-          <a:bodyPr wrap="square" rtlCol="0" anchor="ctr"/>
-          <a:lstStyle/>
-          <a:p>
-            <a:pPr algn="ctr" indent="0" marL="0">
-              <a:buNone/>
-            </a:pPr>
-            <a:r>
-              <a:rPr lang="en-US" sz="1300" dirty="0">
-                <a:solidFill>
-                  <a:srgbClr val="94A3B8"/>
-                </a:solidFill>
-                <a:latin typeface="Calibri" pitchFamily="34" charset="0"/>
-                <a:ea typeface="Calibri" pitchFamily="34" charset="-122"/>
-                <a:cs typeface="Calibri" pitchFamily="34" charset="-120"/>
-              </a:rPr>
-              <a:t>cloud dependencies — fully functional offline and on-premises</a:t>
-            </a:r>
-            <a:endParaRPr lang="en-US" sz="1300" dirty="0"/>
-          </a:p>
-        </p:txBody>
-      </p:sp>
-    </p:spTree>
-  </p:cSld>
-  <p:clrMapOvr>
-    <a:masterClrMapping/>
-  </p:clrMapOvr>
-</p:sld>
-</file>
-
-<file path=ppt/slides/slide8.xml><?xml version="1.0" encoding="utf-8"?>
-<p:sld xmlns:a="http://schemas.openxmlformats.org/drawingml/2006/main" xmlns:r="http://schemas.openxmlformats.org/officeDocument/2006/relationships" xmlns:p="http://schemas.openxmlformats.org/presentationml/2006/main">
-  <p:cSld name="Slide 8">
-    <p:bg>
-      <p:bgPr>
-        <a:solidFill>
-          <a:srgbClr val="FFFFFF"/>
-        </a:solidFill>
-      </p:bgPr>
-    </p:bg>
-    <p:spTree>
-      <p:nvGrpSpPr>
-        <p:cNvPr id="1" name=""/>
-        <p:cNvGrpSpPr/>
-        <p:nvPr/>
-      </p:nvGrpSpPr>
-      <p:grpSpPr>
-        <a:xfrm>
-          <a:off x="0" y="0"/>
-          <a:ext cx="0" cy="0"/>
-          <a:chOff x="0" y="0"/>
-          <a:chExt cx="0" cy="0"/>
-        </a:xfrm>
-      </p:grpSpPr>
-      <p:sp>
-        <p:nvSpPr>
-          <p:cNvPr id="2" name="Text 0"/>
-          <p:cNvSpPr/>
-          <p:nvPr/>
-        </p:nvSpPr>
-        <p:spPr>
-          <a:xfrm>
-            <a:off x="548640" y="320040"/>
-            <a:ext cx="8046720" cy="594360"/>
-          </a:xfrm>
-          <a:prstGeom prst="rect">
-            <a:avLst/>
-          </a:prstGeom>
-          <a:noFill/>
-          <a:ln/>
-        </p:spPr>
-        <p:txBody>
-          <a:bodyPr wrap="square" rtlCol="0" anchor="ctr"/>
-          <a:lstStyle/>
-          <a:p>
-            <a:pPr algn="l" indent="0" marL="0">
-              <a:buNone/>
-            </a:pPr>
-            <a:r>
-              <a:rPr lang="en-US" sz="3200" b="1" dirty="0">
-                <a:solidFill>
-                  <a:srgbClr val="111827"/>
-                </a:solidFill>
-                <a:latin typeface="Cambria" pitchFamily="34" charset="0"/>
-                <a:ea typeface="Cambria" pitchFamily="34" charset="-122"/>
-                <a:cs typeface="Cambria" pitchFamily="34" charset="-120"/>
-              </a:rPr>
-              <a:t>The Team</a:t>
-            </a:r>
-            <a:endParaRPr lang="en-US" sz="3200" dirty="0"/>
-          </a:p>
-        </p:txBody>
-      </p:sp>
-      <p:sp>
-        <p:nvSpPr>
-          <p:cNvPr id="3" name="Shape 1"/>
-          <p:cNvSpPr/>
-          <p:nvPr/>
-        </p:nvSpPr>
-        <p:spPr>
-          <a:xfrm>
-            <a:off x="457200" y="1005840"/>
-            <a:ext cx="4023360" cy="3566160"/>
-          </a:xfrm>
-          <a:prstGeom prst="roundRect">
-            <a:avLst>
-              <a:gd name="adj" fmla="val 3077"/>
-            </a:avLst>
-          </a:prstGeom>
-          <a:solidFill>
-            <a:srgbClr val="F8FAFC"/>
-          </a:solidFill>
-          <a:ln w="12700">
-            <a:solidFill>
-              <a:srgbClr val="E2E8F0"/>
-            </a:solidFill>
-            <a:prstDash val="solid"/>
-          </a:ln>
-          <a:effectLst>
-            <a:outerShdw sx="100000" sy="100000" kx="0" ky="0" algn="bl" rotWithShape="0" blurRad="101600" dist="25400" dir="2700000">
-              <a:srgbClr val="000000">
-                <a:alpha val="10000"/>
-              </a:srgbClr>
-            </a:outerShdw>
-          </a:effectLst>
-        </p:spPr>
-      </p:sp>
-      <p:sp>
-        <p:nvSpPr>
-          <p:cNvPr id="4" name="Shape 2"/>
-          <p:cNvSpPr/>
-          <p:nvPr/>
-        </p:nvSpPr>
-        <p:spPr>
-          <a:xfrm>
-            <a:off x="2011680" y="1188720"/>
-            <a:ext cx="914400" cy="914400"/>
-          </a:xfrm>
-          <a:prstGeom prst="ellipse">
-            <a:avLst/>
-          </a:prstGeom>
-          <a:solidFill>
-            <a:srgbClr val="0F172A"/>
-          </a:solidFill>
-          <a:ln w="12700">
-            <a:solidFill>
-              <a:srgbClr val="0F172A"/>
-            </a:solidFill>
-            <a:prstDash val="solid"/>
-          </a:ln>
-        </p:spPr>
-      </p:sp>
-      <p:sp>
-        <p:nvSpPr>
-          <p:cNvPr id="5" name="Text 3"/>
-          <p:cNvSpPr/>
-          <p:nvPr/>
-        </p:nvSpPr>
-        <p:spPr>
-          <a:xfrm>
-            <a:off x="2011680" y="1188720"/>
-            <a:ext cx="914400" cy="914400"/>
-          </a:xfrm>
-          <a:prstGeom prst="rect">
-            <a:avLst/>
-          </a:prstGeom>
-          <a:noFill/>
-          <a:ln/>
-        </p:spPr>
-        <p:txBody>
-          <a:bodyPr wrap="square" rtlCol="0" anchor="ctr"/>
-          <a:lstStyle/>
-          <a:p>
-            <a:pPr algn="ctr" indent="0" marL="0">
-              <a:buNone/>
-            </a:pPr>
-            <a:r>
-              <a:rPr lang="en-US" sz="2800" b="1" dirty="0">
-                <a:solidFill>
-                  <a:srgbClr val="FFFFFF"/>
-                </a:solidFill>
-                <a:latin typeface="Cambria" pitchFamily="34" charset="0"/>
-                <a:ea typeface="Cambria" pitchFamily="34" charset="-122"/>
-                <a:cs typeface="Cambria" pitchFamily="34" charset="-120"/>
-              </a:rPr>
-              <a:t>J</a:t>
-            </a:r>
-            <a:endParaRPr lang="en-US" sz="2800" dirty="0"/>
-          </a:p>
-        </p:txBody>
-      </p:sp>
-      <p:sp>
-        <p:nvSpPr>
-          <p:cNvPr id="6" name="Text 4"/>
-          <p:cNvSpPr/>
-          <p:nvPr/>
-        </p:nvSpPr>
-        <p:spPr>
-          <a:xfrm>
-            <a:off x="594360" y="2240280"/>
-            <a:ext cx="3749040" cy="411480"/>
-          </a:xfrm>
-          <a:prstGeom prst="rect">
-            <a:avLst/>
-          </a:prstGeom>
-          <a:noFill/>
-          <a:ln/>
-        </p:spPr>
-        <p:txBody>
-          <a:bodyPr wrap="square" rtlCol="0" anchor="ctr"/>
-          <a:lstStyle/>
-          <a:p>
-            <a:pPr algn="ctr" indent="0" marL="0">
-              <a:buNone/>
-            </a:pPr>
-            <a:r>
-              <a:rPr lang="en-US" sz="1600" b="1" dirty="0">
-                <a:solidFill>
-                  <a:srgbClr val="111827"/>
-                </a:solidFill>
-                <a:latin typeface="Calibri" pitchFamily="34" charset="0"/>
-                <a:ea typeface="Calibri" pitchFamily="34" charset="-122"/>
-                <a:cs typeface="Calibri" pitchFamily="34" charset="-120"/>
-              </a:rPr>
-              <a:t>James Wong</a:t>
-            </a:r>
-            <a:endParaRPr lang="en-US" sz="1600" dirty="0"/>
-          </a:p>
-        </p:txBody>
-      </p:sp>
-      <p:sp>
-        <p:nvSpPr>
-          <p:cNvPr id="7" name="Text 5"/>
-          <p:cNvSpPr/>
-          <p:nvPr/>
-        </p:nvSpPr>
-        <p:spPr>
-          <a:xfrm>
-            <a:off x="594360" y="2651760"/>
-            <a:ext cx="3749040" cy="365760"/>
-          </a:xfrm>
-          <a:prstGeom prst="rect">
-            <a:avLst/>
-          </a:prstGeom>
-          <a:noFill/>
-          <a:ln/>
-        </p:spPr>
-        <p:txBody>
-          <a:bodyPr wrap="square" rtlCol="0" anchor="ctr"/>
-          <a:lstStyle/>
-          <a:p>
-            <a:pPr algn="ctr" indent="0" marL="0">
-              <a:buNone/>
-            </a:pPr>
-            <a:r>
-              <a:rPr lang="en-US" sz="1200" b="1" dirty="0">
-                <a:solidFill>
-                  <a:srgbClr val="D97706"/>
-                </a:solidFill>
-                <a:latin typeface="Calibri" pitchFamily="34" charset="0"/>
-                <a:ea typeface="Calibri" pitchFamily="34" charset="-122"/>
-                <a:cs typeface="Calibri" pitchFamily="34" charset="-120"/>
-              </a:rPr>
-              <a:t>Co-founder &amp; Technical Lead</a:t>
-            </a:r>
-            <a:endParaRPr lang="en-US" sz="1200" dirty="0"/>
-          </a:p>
-        </p:txBody>
-      </p:sp>
-      <p:sp>
-        <p:nvSpPr>
-          <p:cNvPr id="8" name="Text 6"/>
-          <p:cNvSpPr/>
-          <p:nvPr/>
-        </p:nvSpPr>
-        <p:spPr>
-          <a:xfrm>
-            <a:off x="640080" y="3108960"/>
-            <a:ext cx="3657600" cy="1097280"/>
-          </a:xfrm>
-          <a:prstGeom prst="rect">
-            <a:avLst/>
-          </a:prstGeom>
-          <a:noFill/>
-          <a:ln/>
-        </p:spPr>
-        <p:txBody>
-          <a:bodyPr wrap="square" rtlCol="0" anchor="ctr"/>
-          <a:lstStyle/>
-          <a:p>
-            <a:pPr algn="l" indent="0" marL="0">
-              <a:buNone/>
-            </a:pPr>
-            <a:r>
-              <a:rPr lang="en-US" sz="1100" dirty="0">
-                <a:solidFill>
-                  <a:srgbClr val="6B7280"/>
-                </a:solidFill>
-                <a:latin typeface="Calibri" pitchFamily="34" charset="0"/>
-                <a:ea typeface="Calibri" pitchFamily="34" charset="-122"/>
-                <a:cs typeface="Calibri" pitchFamily="34" charset="-120"/>
-              </a:rPr>
-              <a:t>Brings technical depth to the architecture, backend design, and local AI inference stack.</a:t>
-            </a:r>
-            <a:endParaRPr lang="en-US" sz="1100" dirty="0"/>
-          </a:p>
-        </p:txBody>
-      </p:sp>
-      <p:sp>
-        <p:nvSpPr>
-          <p:cNvPr id="9" name="Shape 7"/>
-          <p:cNvSpPr/>
-          <p:nvPr/>
-        </p:nvSpPr>
-        <p:spPr>
-          <a:xfrm>
-            <a:off x="4846320" y="1005840"/>
-            <a:ext cx="4023360" cy="3566160"/>
-          </a:xfrm>
-          <a:prstGeom prst="roundRect">
-            <a:avLst>
-              <a:gd name="adj" fmla="val 3077"/>
-            </a:avLst>
-          </a:prstGeom>
-          <a:solidFill>
-            <a:srgbClr val="F8FAFC"/>
-          </a:solidFill>
-          <a:ln w="12700">
-            <a:solidFill>
-              <a:srgbClr val="E2E8F0"/>
-            </a:solidFill>
-            <a:prstDash val="solid"/>
-          </a:ln>
-          <a:effectLst>
-            <a:outerShdw sx="100000" sy="100000" kx="0" ky="0" algn="bl" rotWithShape="0" blurRad="101600" dist="25400" dir="2700000">
-              <a:srgbClr val="000000">
-                <a:alpha val="10000"/>
-              </a:srgbClr>
-            </a:outerShdw>
-          </a:effectLst>
-        </p:spPr>
-      </p:sp>
-      <p:sp>
-        <p:nvSpPr>
-          <p:cNvPr id="10" name="Shape 8"/>
-          <p:cNvSpPr/>
-          <p:nvPr/>
-        </p:nvSpPr>
-        <p:spPr>
-          <a:xfrm>
-            <a:off x="6400800" y="1188720"/>
-            <a:ext cx="914400" cy="914400"/>
-          </a:xfrm>
-          <a:prstGeom prst="ellipse">
-            <a:avLst/>
-          </a:prstGeom>
-          <a:solidFill>
-            <a:srgbClr val="0F172A"/>
-          </a:solidFill>
-          <a:ln w="12700">
-            <a:solidFill>
-              <a:srgbClr val="0F172A"/>
-            </a:solidFill>
-            <a:prstDash val="solid"/>
-          </a:ln>
-        </p:spPr>
-      </p:sp>
-      <p:sp>
-        <p:nvSpPr>
-          <p:cNvPr id="11" name="Text 9"/>
-          <p:cNvSpPr/>
-          <p:nvPr/>
-        </p:nvSpPr>
-        <p:spPr>
-          <a:xfrm>
-            <a:off x="6400800" y="1188720"/>
-            <a:ext cx="914400" cy="914400"/>
-          </a:xfrm>
-          <a:prstGeom prst="rect">
-            <a:avLst/>
-          </a:prstGeom>
-          <a:noFill/>
-          <a:ln/>
-        </p:spPr>
-        <p:txBody>
-          <a:bodyPr wrap="square" rtlCol="0" anchor="ctr"/>
-          <a:lstStyle/>
-          <a:p>
-            <a:pPr algn="ctr" indent="0" marL="0">
-              <a:buNone/>
-            </a:pPr>
-            <a:r>
-              <a:rPr lang="en-US" sz="2800" b="1" dirty="0">
-                <a:solidFill>
-                  <a:srgbClr val="FFFFFF"/>
-                </a:solidFill>
-                <a:latin typeface="Cambria" pitchFamily="34" charset="0"/>
-                <a:ea typeface="Cambria" pitchFamily="34" charset="-122"/>
-                <a:cs typeface="Cambria" pitchFamily="34" charset="-120"/>
-              </a:rPr>
-              <a:t>L</a:t>
-            </a:r>
-            <a:endParaRPr lang="en-US" sz="2800" dirty="0"/>
-          </a:p>
-        </p:txBody>
-      </p:sp>
-      <p:sp>
-        <p:nvSpPr>
-          <p:cNvPr id="12" name="Text 10"/>
-          <p:cNvSpPr/>
-          <p:nvPr/>
-        </p:nvSpPr>
-        <p:spPr>
-          <a:xfrm>
-            <a:off x="4983480" y="2240280"/>
-            <a:ext cx="3749040" cy="411480"/>
-          </a:xfrm>
-          <a:prstGeom prst="rect">
-            <a:avLst/>
-          </a:prstGeom>
-          <a:noFill/>
-          <a:ln/>
-        </p:spPr>
-        <p:txBody>
-          <a:bodyPr wrap="square" rtlCol="0" anchor="ctr"/>
-          <a:lstStyle/>
-          <a:p>
-            <a:pPr algn="ctr" indent="0" marL="0">
-              <a:buNone/>
-            </a:pPr>
-            <a:r>
-              <a:rPr lang="en-US" sz="1600" b="1" dirty="0">
-                <a:solidFill>
-                  <a:srgbClr val="111827"/>
-                </a:solidFill>
-                <a:latin typeface="Calibri" pitchFamily="34" charset="0"/>
-                <a:ea typeface="Calibri" pitchFamily="34" charset="-122"/>
-                <a:cs typeface="Calibri" pitchFamily="34" charset="-120"/>
-              </a:rPr>
-              <a:t>Lionel Lam Song Poh</a:t>
-            </a:r>
-            <a:endParaRPr lang="en-US" sz="1600" dirty="0"/>
-          </a:p>
-        </p:txBody>
-      </p:sp>
-      <p:sp>
-        <p:nvSpPr>
-          <p:cNvPr id="13" name="Text 11"/>
-          <p:cNvSpPr/>
-          <p:nvPr/>
-        </p:nvSpPr>
-        <p:spPr>
-          <a:xfrm>
-            <a:off x="4983480" y="2651760"/>
-            <a:ext cx="3749040" cy="365760"/>
-          </a:xfrm>
-          <a:prstGeom prst="rect">
-            <a:avLst/>
-          </a:prstGeom>
-          <a:noFill/>
-          <a:ln/>
-        </p:spPr>
-        <p:txBody>
-          <a:bodyPr wrap="square" rtlCol="0" anchor="ctr"/>
-          <a:lstStyle/>
-          <a:p>
-            <a:pPr algn="ctr" indent="0" marL="0">
-              <a:buNone/>
-            </a:pPr>
-            <a:r>
-              <a:rPr lang="en-US" sz="1200" b="1" dirty="0">
-                <a:solidFill>
-                  <a:srgbClr val="D97706"/>
-                </a:solidFill>
-                <a:latin typeface="Calibri" pitchFamily="34" charset="0"/>
-                <a:ea typeface="Calibri" pitchFamily="34" charset="-122"/>
-                <a:cs typeface="Calibri" pitchFamily="34" charset="-120"/>
-              </a:rPr>
-              <a:t>Co-founder &amp; Delivery Lead</a:t>
-            </a:r>
-            <a:endParaRPr lang="en-US" sz="1200" dirty="0"/>
-          </a:p>
-        </p:txBody>
-      </p:sp>
-      <p:sp>
-        <p:nvSpPr>
-          <p:cNvPr id="14" name="Text 12"/>
-          <p:cNvSpPr/>
-          <p:nvPr/>
-        </p:nvSpPr>
-        <p:spPr>
-          <a:xfrm>
-            <a:off x="4983480" y="3017520"/>
-            <a:ext cx="3749040" cy="274320"/>
-          </a:xfrm>
-          <a:prstGeom prst="rect">
-            <a:avLst/>
-          </a:prstGeom>
-          <a:noFill/>
-          <a:ln/>
-        </p:spPr>
-        <p:txBody>
-          <a:bodyPr wrap="square" rtlCol="0" anchor="ctr"/>
-          <a:lstStyle/>
-          <a:p>
-            <a:pPr algn="ctr" indent="0" marL="0">
-              <a:buNone/>
-            </a:pPr>
-            <a:r>
-              <a:rPr lang="en-US" sz="1000" i="1" dirty="0">
-                <a:solidFill>
-                  <a:srgbClr val="6B7280"/>
-                </a:solidFill>
-                <a:latin typeface="Calibri" pitchFamily="34" charset="0"/>
-                <a:ea typeface="Calibri" pitchFamily="34" charset="-122"/>
-                <a:cs typeface="Calibri" pitchFamily="34" charset="-120"/>
-              </a:rPr>
-              <a:t>PMP, PMI-ACP, IIBA-AAC, PSM, PSPO</a:t>
-            </a:r>
-            <a:endParaRPr lang="en-US" sz="1000" dirty="0"/>
-          </a:p>
-        </p:txBody>
-      </p:sp>
-      <p:sp>
-        <p:nvSpPr>
-          <p:cNvPr id="15" name="Text 13"/>
-          <p:cNvSpPr/>
-          <p:nvPr/>
-        </p:nvSpPr>
-        <p:spPr>
-          <a:xfrm>
-            <a:off x="5029200" y="3337560"/>
-            <a:ext cx="3657600" cy="1097280"/>
-          </a:xfrm>
-          <a:prstGeom prst="rect">
-            <a:avLst/>
-          </a:prstGeom>
-          <a:noFill/>
-          <a:ln/>
-        </p:spPr>
-        <p:txBody>
-          <a:bodyPr wrap="square" rtlCol="0" anchor="ctr"/>
-          <a:lstStyle/>
-          <a:p>
-            <a:pPr algn="l" indent="0" marL="0">
-              <a:buNone/>
-            </a:pPr>
-            <a:r>
-              <a:rPr lang="en-US" sz="1100" dirty="0">
-                <a:solidFill>
-                  <a:srgbClr val="6B7280"/>
-                </a:solidFill>
-                <a:latin typeface="Calibri" pitchFamily="34" charset="0"/>
-                <a:ea typeface="Calibri" pitchFamily="34" charset="-122"/>
-                <a:cs typeface="Calibri" pitchFamily="34" charset="-120"/>
-              </a:rPr>
-              <a:t>Leads project planning, business analysis, requirements management, and delivery. 15+ years of experience delivering IT projects in Singapore.</a:t>
-            </a:r>
-            <a:endParaRPr lang="en-US" sz="1100" dirty="0"/>
-          </a:p>
-        </p:txBody>
-      </p:sp>
-    </p:spTree>
-  </p:cSld>
-  <p:clrMapOvr>
-    <a:masterClrMapping/>
-  </p:clrMapOvr>
-</p:sld>
-</file>
-
-<file path=ppt/slides/slide9.xml><?xml version="1.0" encoding="utf-8"?>
-<p:sld xmlns:a="http://schemas.openxmlformats.org/drawingml/2006/main" xmlns:r="http://schemas.openxmlformats.org/officeDocument/2006/relationships" xmlns:p="http://schemas.openxmlformats.org/presentationml/2006/main">
-  <p:cSld name="Slide 9">
-    <p:bg>
-      <p:bgPr>
-        <a:solidFill>
-          <a:srgbClr val="0F172A"/>
-        </a:solidFill>
-      </p:bgPr>
-    </p:bg>
-    <p:spTree>
-      <p:nvGrpSpPr>
-        <p:cNvPr id="1" name=""/>
-        <p:cNvGrpSpPr/>
-        <p:nvPr/>
-      </p:nvGrpSpPr>
-      <p:grpSpPr>
-        <a:xfrm>
-          <a:off x="0" y="0"/>
-          <a:ext cx="0" cy="0"/>
-          <a:chOff x="0" y="0"/>
-          <a:chExt cx="0" cy="0"/>
-        </a:xfrm>
-      </p:grpSpPr>
-      <p:sp>
-        <p:nvSpPr>
-          <p:cNvPr id="2" name="Text 0"/>
-          <p:cNvSpPr/>
-          <p:nvPr/>
-        </p:nvSpPr>
-        <p:spPr>
-          <a:xfrm>
-            <a:off x="548640" y="320040"/>
-            <a:ext cx="8046720" cy="594360"/>
-          </a:xfrm>
-          <a:prstGeom prst="rect">
-            <a:avLst/>
-          </a:prstGeom>
-          <a:noFill/>
-          <a:ln/>
-        </p:spPr>
-        <p:txBody>
-          <a:bodyPr wrap="square" rtlCol="0" anchor="ctr"/>
-          <a:lstStyle/>
-          <a:p>
-            <a:pPr algn="l" indent="0" marL="0">
-              <a:buNone/>
-            </a:pPr>
-            <a:r>
-              <a:rPr lang="en-US" sz="3200" b="1" dirty="0">
-                <a:solidFill>
-                  <a:srgbClr val="FFFFFF"/>
-                </a:solidFill>
-                <a:latin typeface="Cambria" pitchFamily="34" charset="0"/>
-                <a:ea typeface="Cambria" pitchFamily="34" charset="-122"/>
-                <a:cs typeface="Cambria" pitchFamily="34" charset="-120"/>
-              </a:rPr>
-              <a:t>Next Steps</a:t>
-            </a:r>
-            <a:endParaRPr lang="en-US" sz="3200" dirty="0"/>
-          </a:p>
-        </p:txBody>
-      </p:sp>
-      <p:sp>
-        <p:nvSpPr>
-          <p:cNvPr id="3" name="Text 1"/>
-          <p:cNvSpPr/>
-          <p:nvPr/>
-        </p:nvSpPr>
-        <p:spPr>
-          <a:xfrm>
-            <a:off x="502920" y="1097280"/>
-            <a:ext cx="594360" cy="685800"/>
-          </a:xfrm>
-          <a:prstGeom prst="rect">
-            <a:avLst/>
-          </a:prstGeom>
-          <a:noFill/>
-          <a:ln/>
-        </p:spPr>
-        <p:txBody>
-          <a:bodyPr wrap="square" rtlCol="0" anchor="ctr"/>
-          <a:lstStyle/>
-          <a:p>
-            <a:pPr algn="l" indent="0" marL="0">
-              <a:buNone/>
-            </a:pPr>
-            <a:r>
-              <a:rPr lang="en-US" sz="2200" b="1" dirty="0">
-                <a:solidFill>
-                  <a:srgbClr val="D97706"/>
-                </a:solidFill>
-                <a:latin typeface="Cambria" pitchFamily="34" charset="0"/>
-                <a:ea typeface="Cambria" pitchFamily="34" charset="-122"/>
-                <a:cs typeface="Cambria" pitchFamily="34" charset="-120"/>
-              </a:rPr>
-              <a:t>01</a:t>
-            </a:r>
-            <a:endParaRPr lang="en-US" sz="2200" dirty="0"/>
-          </a:p>
-        </p:txBody>
-      </p:sp>
-      <p:sp>
-        <p:nvSpPr>
-          <p:cNvPr id="4" name="Text 2"/>
-          <p:cNvSpPr/>
-          <p:nvPr/>
-        </p:nvSpPr>
-        <p:spPr>
-          <a:xfrm>
-            <a:off x="1188720" y="1143000"/>
-            <a:ext cx="7315200" cy="365760"/>
-          </a:xfrm>
-          <a:prstGeom prst="rect">
-            <a:avLst/>
-          </a:prstGeom>
-          <a:noFill/>
-          <a:ln/>
-        </p:spPr>
-        <p:txBody>
-          <a:bodyPr wrap="square" rtlCol="0" anchor="ctr"/>
-          <a:lstStyle/>
-          <a:p>
-            <a:pPr algn="l" indent="0" marL="0">
-              <a:buNone/>
-            </a:pPr>
-            <a:r>
-              <a:rPr lang="en-US" sz="1500" b="1" dirty="0">
-                <a:solidFill>
-                  <a:srgbClr val="FFFFFF"/>
-                </a:solidFill>
-                <a:latin typeface="Calibri" pitchFamily="34" charset="0"/>
-                <a:ea typeface="Calibri" pitchFamily="34" charset="-122"/>
-                <a:cs typeface="Calibri" pitchFamily="34" charset="-120"/>
-              </a:rPr>
-              <a:t>Finalise the process flow diagram</a:t>
-            </a:r>
-            <a:endParaRPr lang="en-US" sz="1500" dirty="0"/>
-          </a:p>
-        </p:txBody>
-      </p:sp>
-      <p:sp>
-        <p:nvSpPr>
-          <p:cNvPr id="5" name="Text 3"/>
-          <p:cNvSpPr/>
-          <p:nvPr/>
-        </p:nvSpPr>
-        <p:spPr>
-          <a:xfrm>
-            <a:off x="1188720" y="1481328"/>
-            <a:ext cx="7315200" cy="347472"/>
-          </a:xfrm>
-          <a:prstGeom prst="rect">
-            <a:avLst/>
-          </a:prstGeom>
-          <a:noFill/>
-          <a:ln/>
-        </p:spPr>
-        <p:txBody>
-          <a:bodyPr wrap="square" rtlCol="0" anchor="ctr"/>
-          <a:lstStyle/>
-          <a:p>
-            <a:pPr algn="l" indent="0" marL="0">
-              <a:buNone/>
-            </a:pPr>
-            <a:r>
-              <a:rPr lang="en-US" sz="1200" dirty="0">
-                <a:solidFill>
-                  <a:srgbClr val="94A3B8"/>
-                </a:solidFill>
-                <a:latin typeface="Calibri" pitchFamily="34" charset="0"/>
-                <a:ea typeface="Calibri" pitchFamily="34" charset="-122"/>
-                <a:cs typeface="Calibri" pitchFamily="34" charset="-120"/>
-              </a:rPr>
-              <a:t>Produce the formal UPN diagram in Miro and align with the team.</a:t>
-            </a:r>
-            <a:endParaRPr lang="en-US" sz="1200" dirty="0"/>
-          </a:p>
-        </p:txBody>
-      </p:sp>
-      <p:sp>
-        <p:nvSpPr>
-          <p:cNvPr id="6" name="Shape 4"/>
-          <p:cNvSpPr/>
-          <p:nvPr/>
-        </p:nvSpPr>
-        <p:spPr>
-          <a:xfrm>
-            <a:off x="502920" y="1874520"/>
-            <a:ext cx="8138160" cy="0"/>
-          </a:xfrm>
-          <a:prstGeom prst="line">
-            <a:avLst/>
-          </a:prstGeom>
-          <a:noFill/>
-          <a:ln w="12700">
-            <a:solidFill>
-              <a:srgbClr val="1E293B"/>
-            </a:solidFill>
-            <a:prstDash val="solid"/>
-          </a:ln>
-        </p:spPr>
-      </p:sp>
-      <p:sp>
-        <p:nvSpPr>
-          <p:cNvPr id="7" name="Text 5"/>
-          <p:cNvSpPr/>
-          <p:nvPr/>
-        </p:nvSpPr>
-        <p:spPr>
-          <a:xfrm>
-            <a:off x="502920" y="2011680"/>
-            <a:ext cx="594360" cy="685800"/>
-          </a:xfrm>
-          <a:prstGeom prst="rect">
-            <a:avLst/>
-          </a:prstGeom>
-          <a:noFill/>
-          <a:ln/>
-        </p:spPr>
-        <p:txBody>
-          <a:bodyPr wrap="square" rtlCol="0" anchor="ctr"/>
-          <a:lstStyle/>
-          <a:p>
-            <a:pPr algn="l" indent="0" marL="0">
-              <a:buNone/>
-            </a:pPr>
-            <a:r>
-              <a:rPr lang="en-US" sz="2200" b="1" dirty="0">
-                <a:solidFill>
-                  <a:srgbClr val="D97706"/>
-                </a:solidFill>
-                <a:latin typeface="Cambria" pitchFamily="34" charset="0"/>
-                <a:ea typeface="Cambria" pitchFamily="34" charset="-122"/>
-                <a:cs typeface="Cambria" pitchFamily="34" charset="-120"/>
-              </a:rPr>
-              <a:t>02</a:t>
-            </a:r>
-            <a:endParaRPr lang="en-US" sz="2200" dirty="0"/>
-          </a:p>
-        </p:txBody>
-      </p:sp>
-      <p:sp>
-        <p:nvSpPr>
-          <p:cNvPr id="8" name="Text 6"/>
-          <p:cNvSpPr/>
-          <p:nvPr/>
-        </p:nvSpPr>
-        <p:spPr>
-          <a:xfrm>
-            <a:off x="1188720" y="2057400"/>
-            <a:ext cx="7315200" cy="365760"/>
-          </a:xfrm>
-          <a:prstGeom prst="rect">
-            <a:avLst/>
-          </a:prstGeom>
-          <a:noFill/>
-          <a:ln/>
-        </p:spPr>
-        <p:txBody>
-          <a:bodyPr wrap="square" rtlCol="0" anchor="ctr"/>
-          <a:lstStyle/>
-          <a:p>
-            <a:pPr algn="l" indent="0" marL="0">
-              <a:buNone/>
-            </a:pPr>
-            <a:r>
-              <a:rPr lang="en-US" sz="1500" b="1" dirty="0">
-                <a:solidFill>
-                  <a:srgbClr val="FFFFFF"/>
-                </a:solidFill>
-                <a:latin typeface="Calibri" pitchFamily="34" charset="0"/>
-                <a:ea typeface="Calibri" pitchFamily="34" charset="-122"/>
-                <a:cs typeface="Calibri" pitchFamily="34" charset="-120"/>
-              </a:rPr>
-              <a:t>Define the starter category list</a:t>
-            </a:r>
-            <a:endParaRPr lang="en-US" sz="1500" dirty="0"/>
-          </a:p>
-        </p:txBody>
-      </p:sp>
-      <p:sp>
-        <p:nvSpPr>
-          <p:cNvPr id="9" name="Text 7"/>
-          <p:cNvSpPr/>
-          <p:nvPr/>
-        </p:nvSpPr>
-        <p:spPr>
-          <a:xfrm>
-            <a:off x="1188720" y="2395728"/>
-            <a:ext cx="7315200" cy="347472"/>
-          </a:xfrm>
-          <a:prstGeom prst="rect">
-            <a:avLst/>
-          </a:prstGeom>
-          <a:noFill/>
-          <a:ln/>
-        </p:spPr>
-        <p:txBody>
-          <a:bodyPr wrap="square" rtlCol="0" anchor="ctr"/>
-          <a:lstStyle/>
-          <a:p>
-            <a:pPr algn="l" indent="0" marL="0">
-              <a:buNone/>
-            </a:pPr>
-            <a:r>
-              <a:rPr lang="en-US" sz="1200" dirty="0">
-                <a:solidFill>
-                  <a:srgbClr val="94A3B8"/>
-                </a:solidFill>
-                <a:latin typeface="Calibri" pitchFamily="34" charset="0"/>
-                <a:ea typeface="Calibri" pitchFamily="34" charset="-122"/>
-                <a:cs typeface="Calibri" pitchFamily="34" charset="-120"/>
-              </a:rPr>
-              <a:t>Agree on the seeded category taxonomy for new user profiles.</a:t>
-            </a:r>
-            <a:endParaRPr lang="en-US" sz="1200" dirty="0"/>
-          </a:p>
-        </p:txBody>
-      </p:sp>
-      <p:sp>
-        <p:nvSpPr>
-          <p:cNvPr id="10" name="Shape 8"/>
-          <p:cNvSpPr/>
-          <p:nvPr/>
-        </p:nvSpPr>
-        <p:spPr>
-          <a:xfrm>
-            <a:off x="502920" y="2788920"/>
-            <a:ext cx="8138160" cy="0"/>
-          </a:xfrm>
-          <a:prstGeom prst="line">
-            <a:avLst/>
-          </a:prstGeom>
-          <a:noFill/>
-          <a:ln w="12700">
-            <a:solidFill>
-              <a:srgbClr val="1E293B"/>
-            </a:solidFill>
-            <a:prstDash val="solid"/>
-          </a:ln>
-        </p:spPr>
-      </p:sp>
-      <p:sp>
-        <p:nvSpPr>
-          <p:cNvPr id="11" name="Text 9"/>
-          <p:cNvSpPr/>
-          <p:nvPr/>
-        </p:nvSpPr>
-        <p:spPr>
-          <a:xfrm>
-            <a:off x="502920" y="2926080"/>
-            <a:ext cx="594360" cy="685800"/>
-          </a:xfrm>
-          <a:prstGeom prst="rect">
-            <a:avLst/>
-          </a:prstGeom>
-          <a:noFill/>
-          <a:ln/>
-        </p:spPr>
-        <p:txBody>
-          <a:bodyPr wrap="square" rtlCol="0" anchor="ctr"/>
-          <a:lstStyle/>
-          <a:p>
-            <a:pPr algn="l" indent="0" marL="0">
-              <a:buNone/>
-            </a:pPr>
-            <a:r>
-              <a:rPr lang="en-US" sz="2200" b="1" dirty="0">
-                <a:solidFill>
-                  <a:srgbClr val="D97706"/>
-                </a:solidFill>
-                <a:latin typeface="Cambria" pitchFamily="34" charset="0"/>
-                <a:ea typeface="Cambria" pitchFamily="34" charset="-122"/>
-                <a:cs typeface="Cambria" pitchFamily="34" charset="-120"/>
-              </a:rPr>
-              <a:t>03</a:t>
-            </a:r>
-            <a:endParaRPr lang="en-US" sz="2200" dirty="0"/>
-          </a:p>
-        </p:txBody>
-      </p:sp>
-      <p:sp>
-        <p:nvSpPr>
-          <p:cNvPr id="12" name="Text 10"/>
-          <p:cNvSpPr/>
-          <p:nvPr/>
-        </p:nvSpPr>
-        <p:spPr>
-          <a:xfrm>
-            <a:off x="1188720" y="2971800"/>
-            <a:ext cx="7315200" cy="365760"/>
-          </a:xfrm>
-          <a:prstGeom prst="rect">
-            <a:avLst/>
-          </a:prstGeom>
-          <a:noFill/>
-          <a:ln/>
-        </p:spPr>
-        <p:txBody>
-          <a:bodyPr wrap="square" rtlCol="0" anchor="ctr"/>
-          <a:lstStyle/>
-          <a:p>
-            <a:pPr algn="l" indent="0" marL="0">
-              <a:buNone/>
-            </a:pPr>
-            <a:r>
-              <a:rPr lang="en-US" sz="1500" b="1" dirty="0">
-                <a:solidFill>
-                  <a:srgbClr val="FFFFFF"/>
-                </a:solidFill>
-                <a:latin typeface="Calibri" pitchFamily="34" charset="0"/>
-                <a:ea typeface="Calibri" pitchFamily="34" charset="-122"/>
-                <a:cs typeface="Calibri" pitchFamily="34" charset="-120"/>
-              </a:rPr>
-              <a:t>Break down into backlog</a:t>
-            </a:r>
-            <a:endParaRPr lang="en-US" sz="1500" dirty="0"/>
-          </a:p>
-        </p:txBody>
-      </p:sp>
-      <p:sp>
-        <p:nvSpPr>
-          <p:cNvPr id="13" name="Text 11"/>
-          <p:cNvSpPr/>
-          <p:nvPr/>
-        </p:nvSpPr>
-        <p:spPr>
-          <a:xfrm>
-            <a:off x="1188720" y="3310128"/>
-            <a:ext cx="7315200" cy="347472"/>
-          </a:xfrm>
-          <a:prstGeom prst="rect">
-            <a:avLst/>
-          </a:prstGeom>
-          <a:noFill/>
-          <a:ln/>
-        </p:spPr>
-        <p:txBody>
-          <a:bodyPr wrap="square" rtlCol="0" anchor="ctr"/>
-          <a:lstStyle/>
-          <a:p>
-            <a:pPr algn="l" indent="0" marL="0">
-              <a:buNone/>
-            </a:pPr>
-            <a:r>
-              <a:rPr lang="en-US" sz="1200" dirty="0">
-                <a:solidFill>
-                  <a:srgbClr val="94A3B8"/>
-                </a:solidFill>
-                <a:latin typeface="Calibri" pitchFamily="34" charset="0"/>
-                <a:ea typeface="Calibri" pitchFamily="34" charset="-122"/>
-                <a:cs typeface="Calibri" pitchFamily="34" charset="-120"/>
-              </a:rPr>
-              <a:t>Decompose Phase 1 into user stories and a story map ready for development.</a:t>
-            </a:r>
-            <a:endParaRPr lang="en-US" sz="1200" dirty="0"/>
-          </a:p>
-        </p:txBody>
-      </p:sp>
-      <p:sp>
-        <p:nvSpPr>
-          <p:cNvPr id="14" name="Shape 12"/>
-          <p:cNvSpPr/>
-          <p:nvPr/>
-        </p:nvSpPr>
-        <p:spPr>
-          <a:xfrm>
-            <a:off x="502920" y="3703320"/>
-            <a:ext cx="8138160" cy="0"/>
-          </a:xfrm>
-          <a:prstGeom prst="line">
-            <a:avLst/>
-          </a:prstGeom>
-          <a:noFill/>
-          <a:ln w="12700">
-            <a:solidFill>
-              <a:srgbClr val="1E293B"/>
-            </a:solidFill>
-            <a:prstDash val="solid"/>
-          </a:ln>
-        </p:spPr>
-      </p:sp>
-      <p:sp>
-        <p:nvSpPr>
-          <p:cNvPr id="15" name="Text 13"/>
-          <p:cNvSpPr/>
-          <p:nvPr/>
-        </p:nvSpPr>
-        <p:spPr>
-          <a:xfrm>
-            <a:off x="502920" y="3840480"/>
-            <a:ext cx="594360" cy="685800"/>
-          </a:xfrm>
-          <a:prstGeom prst="rect">
-            <a:avLst/>
-          </a:prstGeom>
-          <a:noFill/>
-          <a:ln/>
-        </p:spPr>
-        <p:txBody>
-          <a:bodyPr wrap="square" rtlCol="0" anchor="ctr"/>
-          <a:lstStyle/>
-          <a:p>
-            <a:pPr algn="l" indent="0" marL="0">
-              <a:buNone/>
-            </a:pPr>
-            <a:r>
-              <a:rPr lang="en-US" sz="2200" b="1" dirty="0">
-                <a:solidFill>
-                  <a:srgbClr val="D97706"/>
-                </a:solidFill>
-                <a:latin typeface="Cambria" pitchFamily="34" charset="0"/>
-                <a:ea typeface="Cambria" pitchFamily="34" charset="-122"/>
-                <a:cs typeface="Cambria" pitchFamily="34" charset="-120"/>
-              </a:rPr>
-              <a:t>04</a:t>
-            </a:r>
-            <a:endParaRPr lang="en-US" sz="2200" dirty="0"/>
-          </a:p>
-        </p:txBody>
-      </p:sp>
-      <p:sp>
-        <p:nvSpPr>
-          <p:cNvPr id="16" name="Text 14"/>
-          <p:cNvSpPr/>
-          <p:nvPr/>
-        </p:nvSpPr>
-        <p:spPr>
-          <a:xfrm>
-            <a:off x="1188720" y="3886200"/>
-            <a:ext cx="7315200" cy="365760"/>
-          </a:xfrm>
-          <a:prstGeom prst="rect">
-            <a:avLst/>
-          </a:prstGeom>
-          <a:noFill/>
-          <a:ln/>
-        </p:spPr>
-        <p:txBody>
-          <a:bodyPr wrap="square" rtlCol="0" anchor="ctr"/>
-          <a:lstStyle/>
-          <a:p>
-            <a:pPr algn="l" indent="0" marL="0">
-              <a:buNone/>
-            </a:pPr>
-            <a:r>
-              <a:rPr lang="en-US" sz="1500" b="1" dirty="0">
-                <a:solidFill>
-                  <a:srgbClr val="FFFFFF"/>
-                </a:solidFill>
-                <a:latin typeface="Calibri" pitchFamily="34" charset="0"/>
-                <a:ea typeface="Calibri" pitchFamily="34" charset="-122"/>
-                <a:cs typeface="Calibri" pitchFamily="34" charset="-120"/>
-              </a:rPr>
-              <a:t>Set up the development environment</a:t>
-            </a:r>
-            <a:endParaRPr lang="en-US" sz="1500" dirty="0"/>
-          </a:p>
-        </p:txBody>
-      </p:sp>
-      <p:sp>
-        <p:nvSpPr>
-          <p:cNvPr id="17" name="Text 15"/>
-          <p:cNvSpPr/>
-          <p:nvPr/>
-        </p:nvSpPr>
-        <p:spPr>
-          <a:xfrm>
-            <a:off x="1188720" y="4224528"/>
-            <a:ext cx="7315200" cy="347472"/>
-          </a:xfrm>
-          <a:prstGeom prst="rect">
-            <a:avLst/>
-          </a:prstGeom>
-          <a:noFill/>
-          <a:ln/>
-        </p:spPr>
-        <p:txBody>
-          <a:bodyPr wrap="square" rtlCol="0" anchor="ctr"/>
-          <a:lstStyle/>
-          <a:p>
-            <a:pPr algn="l" indent="0" marL="0">
-              <a:buNone/>
-            </a:pPr>
-            <a:r>
-              <a:rPr lang="en-US" sz="1200" dirty="0">
-                <a:solidFill>
-                  <a:srgbClr val="94A3B8"/>
-                </a:solidFill>
-                <a:latin typeface="Calibri" pitchFamily="34" charset="0"/>
-                <a:ea typeface="Calibri" pitchFamily="34" charset="-122"/>
-                <a:cs typeface="Calibri" pitchFamily="34" charset="-120"/>
-              </a:rPr>
-              <a:t>Local dev stack: FastAPI, SQLite, Ollama/Phi-4-mini, containerization approach TBD.</a:t>
-            </a:r>
-            <a:endParaRPr lang="en-US" sz="1200" dirty="0"/>
           </a:p>
         </p:txBody>
       </p:sp>
@@ -6293,4 +4391,319 @@
     </a:ext>
   </a:extLst>
 </a:theme>
+</file>
+
+<file path=ppt/theme/theme2.xml><?xml version="1.0" encoding="utf-8"?>
+<a:theme xmlns:a="http://schemas.openxmlformats.org/drawingml/2006/main" name="Office Theme">
+  <a:themeElements>
+    <a:clrScheme name="Office">
+      <a:dk1>
+        <a:sysClr val="windowText" lastClr="000000"/>
+      </a:dk1>
+      <a:lt1>
+        <a:sysClr val="window" lastClr="FFFFFF"/>
+      </a:lt1>
+      <a:dk2>
+        <a:srgbClr val="0E2841"/>
+      </a:dk2>
+      <a:lt2>
+        <a:srgbClr val="E8E8E8"/>
+      </a:lt2>
+      <a:accent1>
+        <a:srgbClr val="156082"/>
+      </a:accent1>
+      <a:accent2>
+        <a:srgbClr val="E97132"/>
+      </a:accent2>
+      <a:accent3>
+        <a:srgbClr val="196B24"/>
+      </a:accent3>
+      <a:accent4>
+        <a:srgbClr val="0F9ED5"/>
+      </a:accent4>
+      <a:accent5>
+        <a:srgbClr val="A02B93"/>
+      </a:accent5>
+      <a:accent6>
+        <a:srgbClr val="4EA72E"/>
+      </a:accent6>
+      <a:hlink>
+        <a:srgbClr val="467886"/>
+      </a:hlink>
+      <a:folHlink>
+        <a:srgbClr val="96607D"/>
+      </a:folHlink>
+    </a:clrScheme>
+    <a:fontScheme name="Office">
+      <a:majorFont>
+        <a:latin typeface="Aptos Display" panose="02110004020202020204"/>
+        <a:ea typeface=""/>
+        <a:cs typeface=""/>
+        <a:font script="Jpan" typeface="游ゴシック Light"/>
+        <a:font script="Hang" typeface="맑은 고딕"/>
+        <a:font script="Hans" typeface="等线 Light"/>
+        <a:font script="Hant" typeface="新細明體"/>
+        <a:font script="Arab" typeface="Times New Roman"/>
+        <a:font script="Hebr" typeface="Times New Roman"/>
+        <a:font script="Thai" typeface="Angsana New"/>
+        <a:font script="Ethi" typeface="Nyala"/>
+        <a:font script="Beng" typeface="Vrinda"/>
+        <a:font script="Gujr" typeface="Shruti"/>
+        <a:font script="Khmr" typeface="MoolBoran"/>
+        <a:font script="Knda" typeface="Tunga"/>
+        <a:font script="Guru" typeface="Raavi"/>
+        <a:font script="Cans" typeface="Euphemia"/>
+        <a:font script="Cher" typeface="Plantagenet Cherokee"/>
+        <a:font script="Yiii" typeface="Microsoft Yi Baiti"/>
+        <a:font script="Tibt" typeface="Microsoft Himalaya"/>
+        <a:font script="Thaa" typeface="MV Boli"/>
+        <a:font script="Deva" typeface="Mangal"/>
+        <a:font script="Telu" typeface="Gautami"/>
+        <a:font script="Taml" typeface="Latha"/>
+        <a:font script="Syrc" typeface="Estrangelo Edessa"/>
+        <a:font script="Orya" typeface="Kalinga"/>
+        <a:font script="Mlym" typeface="Kartika"/>
+        <a:font script="Laoo" typeface="DokChampa"/>
+        <a:font script="Sinh" typeface="Iskoola Pota"/>
+        <a:font script="Mong" typeface="Mongolian Baiti"/>
+        <a:font script="Viet" typeface="Times New Roman"/>
+        <a:font script="Uigh" typeface="Microsoft Uighur"/>
+        <a:font script="Geor" typeface="Sylfaen"/>
+        <a:font script="Armn" typeface="Arial"/>
+        <a:font script="Bugi" typeface="Leelawadee UI"/>
+        <a:font script="Bopo" typeface="Microsoft JhengHei"/>
+        <a:font script="Java" typeface="Javanese Text"/>
+        <a:font script="Lisu" typeface="Segoe UI"/>
+        <a:font script="Mymr" typeface="Myanmar Text"/>
+        <a:font script="Nkoo" typeface="Ebrima"/>
+        <a:font script="Olck" typeface="Nirmala UI"/>
+        <a:font script="Osma" typeface="Ebrima"/>
+        <a:font script="Phag" typeface="Phagspa"/>
+        <a:font script="Syrn" typeface="Estrangelo Edessa"/>
+        <a:font script="Syrj" typeface="Estrangelo Edessa"/>
+        <a:font script="Syre" typeface="Estrangelo Edessa"/>
+        <a:font script="Sora" typeface="Nirmala UI"/>
+        <a:font script="Tale" typeface="Microsoft Tai Le"/>
+        <a:font script="Talu" typeface="Microsoft New Tai Lue"/>
+        <a:font script="Tfng" typeface="Ebrima"/>
+      </a:majorFont>
+      <a:minorFont>
+        <a:latin typeface="Aptos" panose="02110004020202020204"/>
+        <a:ea typeface=""/>
+        <a:cs typeface=""/>
+        <a:font script="Jpan" typeface="游ゴシック"/>
+        <a:font script="Hang" typeface="맑은 고딕"/>
+        <a:font script="Hans" typeface="等线"/>
+        <a:font script="Hant" typeface="新細明體"/>
+        <a:font script="Arab" typeface="Arial"/>
+        <a:font script="Hebr" typeface="Arial"/>
+        <a:font script="Thai" typeface="Cordia New"/>
+        <a:font script="Ethi" typeface="Nyala"/>
+        <a:font script="Beng" typeface="Vrinda"/>
+        <a:font script="Gujr" typeface="Shruti"/>
+        <a:font script="Khmr" typeface="DaunPenh"/>
+        <a:font script="Knda" typeface="Tunga"/>
+        <a:font script="Guru" typeface="Raavi"/>
+        <a:font script="Cans" typeface="Euphemia"/>
+        <a:font script="Cher" typeface="Plantagenet Cherokee"/>
+        <a:font script="Yiii" typeface="Microsoft Yi Baiti"/>
+        <a:font script="Tibt" typeface="Microsoft Himalaya"/>
+        <a:font script="Thaa" typeface="MV Boli"/>
+        <a:font script="Deva" typeface="Mangal"/>
+        <a:font script="Telu" typeface="Gautami"/>
+        <a:font script="Taml" typeface="Latha"/>
+        <a:font script="Syrc" typeface="Estrangelo Edessa"/>
+        <a:font script="Orya" typeface="Kalinga"/>
+        <a:font script="Mlym" typeface="Kartika"/>
+        <a:font script="Laoo" typeface="DokChampa"/>
+        <a:font script="Sinh" typeface="Iskoola Pota"/>
+        <a:font script="Mong" typeface="Mongolian Baiti"/>
+        <a:font script="Viet" typeface="Arial"/>
+        <a:font script="Uigh" typeface="Microsoft Uighur"/>
+        <a:font script="Geor" typeface="Sylfaen"/>
+        <a:font script="Armn" typeface="Arial"/>
+        <a:font script="Bugi" typeface="Leelawadee UI"/>
+        <a:font script="Bopo" typeface="Microsoft JhengHei"/>
+        <a:font script="Java" typeface="Javanese Text"/>
+        <a:font script="Lisu" typeface="Segoe UI"/>
+        <a:font script="Mymr" typeface="Myanmar Text"/>
+        <a:font script="Nkoo" typeface="Ebrima"/>
+        <a:font script="Olck" typeface="Nirmala UI"/>
+        <a:font script="Osma" typeface="Ebrima"/>
+        <a:font script="Phag" typeface="Phagspa"/>
+        <a:font script="Syrn" typeface="Estrangelo Edessa"/>
+        <a:font script="Syrj" typeface="Estrangelo Edessa"/>
+        <a:font script="Syre" typeface="Estrangelo Edessa"/>
+        <a:font script="Sora" typeface="Nirmala UI"/>
+        <a:font script="Tale" typeface="Microsoft Tai Le"/>
+        <a:font script="Talu" typeface="Microsoft New Tai Lue"/>
+        <a:font script="Tfng" typeface="Ebrima"/>
+      </a:minorFont>
+    </a:fontScheme>
+    <a:fmtScheme name="Office">
+      <a:fillStyleLst>
+        <a:solidFill>
+          <a:schemeClr val="phClr"/>
+        </a:solidFill>
+        <a:gradFill rotWithShape="1">
+          <a:gsLst>
+            <a:gs pos="0">
+              <a:schemeClr val="phClr">
+                <a:lumMod val="110000"/>
+                <a:satMod val="105000"/>
+                <a:tint val="67000"/>
+              </a:schemeClr>
+            </a:gs>
+            <a:gs pos="50000">
+              <a:schemeClr val="phClr">
+                <a:lumMod val="105000"/>
+                <a:satMod val="103000"/>
+                <a:tint val="73000"/>
+              </a:schemeClr>
+            </a:gs>
+            <a:gs pos="100000">
+              <a:schemeClr val="phClr">
+                <a:lumMod val="105000"/>
+                <a:satMod val="109000"/>
+                <a:tint val="81000"/>
+              </a:schemeClr>
+            </a:gs>
+          </a:gsLst>
+          <a:lin ang="5400000" scaled="0"/>
+        </a:gradFill>
+        <a:gradFill rotWithShape="1">
+          <a:gsLst>
+            <a:gs pos="0">
+              <a:schemeClr val="phClr">
+                <a:satMod val="103000"/>
+                <a:lumMod val="102000"/>
+                <a:tint val="94000"/>
+              </a:schemeClr>
+            </a:gs>
+            <a:gs pos="50000">
+              <a:schemeClr val="phClr">
+                <a:satMod val="110000"/>
+                <a:lumMod val="100000"/>
+                <a:shade val="100000"/>
+              </a:schemeClr>
+            </a:gs>
+            <a:gs pos="100000">
+              <a:schemeClr val="phClr">
+                <a:lumMod val="99000"/>
+                <a:satMod val="120000"/>
+                <a:shade val="78000"/>
+              </a:schemeClr>
+            </a:gs>
+          </a:gsLst>
+          <a:lin ang="5400000" scaled="0"/>
+        </a:gradFill>
+      </a:fillStyleLst>
+      <a:lnStyleLst>
+        <a:ln w="12700" cap="flat" cmpd="sng" algn="ctr">
+          <a:solidFill>
+            <a:schemeClr val="phClr"/>
+          </a:solidFill>
+          <a:prstDash val="solid"/>
+          <a:miter lim="800000"/>
+        </a:ln>
+        <a:ln w="19050" cap="flat" cmpd="sng" algn="ctr">
+          <a:solidFill>
+            <a:schemeClr val="phClr"/>
+          </a:solidFill>
+          <a:prstDash val="solid"/>
+          <a:miter lim="800000"/>
+        </a:ln>
+        <a:ln w="25400" cap="flat" cmpd="sng" algn="ctr">
+          <a:solidFill>
+            <a:schemeClr val="phClr"/>
+          </a:solidFill>
+          <a:prstDash val="solid"/>
+          <a:miter lim="800000"/>
+        </a:ln>
+      </a:lnStyleLst>
+      <a:effectStyleLst>
+        <a:effectStyle>
+          <a:effectLst/>
+        </a:effectStyle>
+        <a:effectStyle>
+          <a:effectLst/>
+        </a:effectStyle>
+        <a:effectStyle>
+          <a:effectLst>
+            <a:outerShdw blurRad="57150" dist="19050" dir="5400000" algn="ctr" rotWithShape="0">
+              <a:srgbClr val="000000">
+                <a:alpha val="63000"/>
+              </a:srgbClr>
+            </a:outerShdw>
+          </a:effectLst>
+        </a:effectStyle>
+      </a:effectStyleLst>
+      <a:bgFillStyleLst>
+        <a:solidFill>
+          <a:schemeClr val="phClr"/>
+        </a:solidFill>
+        <a:solidFill>
+          <a:schemeClr val="phClr">
+            <a:tint val="95000"/>
+            <a:satMod val="170000"/>
+          </a:schemeClr>
+        </a:solidFill>
+        <a:gradFill rotWithShape="1">
+          <a:gsLst>
+            <a:gs pos="0">
+              <a:schemeClr val="phClr">
+                <a:tint val="93000"/>
+                <a:satMod val="150000"/>
+                <a:shade val="98000"/>
+                <a:lumMod val="102000"/>
+              </a:schemeClr>
+            </a:gs>
+            <a:gs pos="50000">
+              <a:schemeClr val="phClr">
+                <a:tint val="98000"/>
+                <a:satMod val="130000"/>
+                <a:shade val="90000"/>
+                <a:lumMod val="103000"/>
+              </a:schemeClr>
+            </a:gs>
+            <a:gs pos="100000">
+              <a:schemeClr val="phClr">
+                <a:shade val="63000"/>
+                <a:satMod val="120000"/>
+              </a:schemeClr>
+            </a:gs>
+          </a:gsLst>
+          <a:lin ang="5400000" scaled="0"/>
+        </a:gradFill>
+      </a:bgFillStyleLst>
+    </a:fmtScheme>
+  </a:themeElements>
+  <a:objectDefaults>
+    <a:lnDef>
+      <a:spPr/>
+      <a:bodyPr/>
+      <a:lstStyle/>
+      <a:style>
+        <a:lnRef idx="2">
+          <a:schemeClr val="accent1"/>
+        </a:lnRef>
+        <a:fillRef idx="0">
+          <a:schemeClr val="accent1"/>
+        </a:fillRef>
+        <a:effectRef idx="1">
+          <a:schemeClr val="accent1"/>
+        </a:effectRef>
+        <a:fontRef idx="minor">
+          <a:schemeClr val="tx1"/>
+        </a:fontRef>
+      </a:style>
+    </a:lnDef>
+  </a:objectDefaults>
+  <a:extraClrSchemeLst/>
+  <a:extLst>
+    <a:ext uri="{05A4C25C-085E-4340-85A3-A5531E510DB2}">
+      <thm15:themeFamily xmlns:thm15="http://schemas.microsoft.com/office/thememl/2012/main" name="Office Theme" id="{2E142A2C-CD16-42D6-873A-C26D2A0506FA}" vid="{1BDDFF52-6CD6-40A5-AB3C-68EB2F1E4D0A}"/>
+    </a:ext>
+  </a:extLst>
+</a:theme>
 </file>
</xml_diff>